<commit_message>
Fix PowerPoint header shapes and avatar placement
Co-Authored-By: Claude Sonnet 5.5 <noreply@anthropic.com>
Claude-Session: https://claude.ai/code/session_01AK9pnJM83quWWTt8tkL4QY
</commit_message>
<xml_diff>
--- a/microclase-pedir-repetir.pptx
+++ b/microclase-pedir-repetir.pptx
@@ -117,49 +117,49 @@
   <p:extLst>
     <p:ext uri="{521415D9-36F7-43E2-AB2F-B90AF26B5E84}">
       <p14:sectionLst xmlns:p14="http://schemas.microsoft.com/office/powerpoint/2010/main">
-        <p14:section name="Apertura" id="{39d24fef-3e18-30d2-f971-5c8c0f381b68}">
+        <p14:section name="Apertura" id="{d0058f10-0226-132d-b8f7-5cea3739647d}">
           <p14:sldIdLst>
             <p14:sldId id="256"/>
           </p14:sldIdLst>
         </p14:section>
-        <p14:section name="Situación" id="{23ac37d3-7fa5-8913-c2aa-0c48dee6b474}">
+        <p14:section name="Situación" id="{7a8208f8-8dbc-c459-2f7e-b0c82fc18d93}">
           <p14:sldIdLst>
             <p14:sldId id="257"/>
           </p14:sldIdLst>
         </p14:section>
-        <p14:section name="Expresión 1" id="{e228c3c0-efff-cfae-de10-dfdb6a3a3dc7}">
+        <p14:section name="Expresión 1" id="{8829f43a-c92b-7990-a9f3-1ba954a28023}">
           <p14:sldIdLst>
             <p14:sldId id="258"/>
           </p14:sldIdLst>
         </p14:section>
-        <p14:section name="Modelado" id="{6289e37a-f612-0851-76ab-4cf5d3412fa5}">
+        <p14:section name="Modelado" id="{bcf3456a-59cf-c025-cb59-0612ef634003}">
           <p14:sldIdLst>
             <p14:sldId id="259"/>
           </p14:sldIdLst>
         </p14:section>
-        <p14:section name="Expresión 2" id="{2053c54c-32c6-fecc-84d8-f1e8d4bffa9d}">
+        <p14:section name="Expresión 2" id="{9901df5f-e4c7-10ae-67fa-5c365fdb5670}">
           <p14:sldIdLst>
             <p14:sldId id="260"/>
           </p14:sldIdLst>
         </p14:section>
-        <p14:section name="Ejemplo" id="{b7aa274d-1c7a-6a8e-0a6e-5489f2c3f42a}">
+        <p14:section name="Ejemplo" id="{08cb9061-87cc-8185-1a1a-90537d9cc8aa}">
           <p14:sldIdLst>
             <p14:sldId id="261"/>
           </p14:sldIdLst>
         </p14:section>
-        <p14:section name="Práctica guiada" id="{53ebea8d-cadd-824e-49a1-108d1ff62ecc}">
+        <p14:section name="Práctica guiada" id="{7174dcd9-e18c-3657-b84c-b3dc9cf983cd}">
           <p14:sldIdLst>
             <p14:sldId id="262"/>
             <p14:sldId id="263"/>
           </p14:sldIdLst>
         </p14:section>
-        <p14:section name="Comprobación" id="{8c1c8730-8df9-5aa8-3fc8-c092c8193a80}">
+        <p14:section name="Comprobación" id="{a6b2eee7-b774-26f5-517c-1837cf296c0d}">
           <p14:sldIdLst>
             <p14:sldId id="264"/>
             <p14:sldId id="265"/>
           </p14:sldIdLst>
         </p14:section>
-        <p14:section name="Cierre" id="{6ef2fe58-5f18-178b-18fe-06d418af6589}">
+        <p14:section name="Cierre" id="{d877ee90-3c5f-5511-3945-c9c10375c473}">
           <p14:sldIdLst>
             <p14:sldId id="266"/>
           </p14:sldIdLst>
@@ -1592,45 +1592,6 @@
         </p:nvSpPr>
         <p:spPr>
           <a:xfrm>
-            <a:off x="457200" y="118872"/>
-            <a:ext cx="548640" cy="548640"/>
-          </a:xfrm>
-          <a:prstGeom prst="rect">
-            <a:avLst/>
-          </a:prstGeom>
-          <a:noFill/>
-          <a:ln/>
-        </p:spPr>
-        <p:txBody>
-          <a:bodyPr wrap="square" lIns="0" tIns="0" rIns="0" bIns="0" rtlCol="0" anchor="ctr"/>
-          <a:lstStyle/>
-          <a:p>
-            <a:pPr algn="ctr" indent="0" marL="0">
-              <a:buNone/>
-            </a:pPr>
-            <a:r>
-              <a:rPr lang="en-US" sz="2000" b="1" dirty="0">
-                <a:solidFill>
-                  <a:schemeClr val="tx1"/>
-                </a:solidFill>
-                <a:latin typeface="Big Shoulders Display" pitchFamily="34" charset="0"/>
-                <a:ea typeface="Big Shoulders Display" pitchFamily="34" charset="-122"/>
-                <a:cs typeface="Big Shoulders Display" pitchFamily="34" charset="-120"/>
-              </a:rPr>
-              <a:t>MM</a:t>
-            </a:r>
-            <a:endParaRPr lang="en-US" sz="2000" dirty="0"/>
-          </a:p>
-        </p:txBody>
-      </p:sp>
-      <p:sp>
-        <p:nvSpPr>
-          <p:cNvPr id="4" name="Text 2"/>
-          <p:cNvSpPr/>
-          <p:nvPr/>
-        </p:nvSpPr>
-        <p:spPr>
-          <a:xfrm>
             <a:off x="1188720" y="118872"/>
             <a:ext cx="4572000" cy="548640"/>
           </a:xfrm>
@@ -1664,14 +1625,14 @@
       </p:sp>
       <p:sp>
         <p:nvSpPr>
-          <p:cNvPr id="5" name="Text 3"/>
+          <p:cNvPr id="4" name="Text 2"/>
           <p:cNvSpPr/>
           <p:nvPr/>
         </p:nvSpPr>
         <p:spPr>
           <a:xfrm>
-            <a:off x="8915400" y="182880"/>
-            <a:ext cx="2743200" cy="411480"/>
+            <a:off x="548640" y="6473952"/>
+            <a:ext cx="8229600" cy="292608"/>
           </a:xfrm>
           <a:prstGeom prst="rect">
             <a:avLst/>
@@ -1683,11 +1644,11 @@
           <a:bodyPr wrap="square" lIns="0" tIns="0" rIns="0" bIns="0" rtlCol="0" anchor="ctr"/>
           <a:lstStyle/>
           <a:p>
-            <a:pPr algn="ctr" indent="0" marL="0">
-              <a:buNone/>
-            </a:pPr>
-            <a:r>
-              <a:rPr lang="en-US" sz="1400" b="1" dirty="0">
+            <a:pPr indent="0" marL="0">
+              <a:buNone/>
+            </a:pPr>
+            <a:r>
+              <a:rPr lang="en-US" sz="1100" dirty="0">
                 <a:solidFill>
                   <a:schemeClr val="tx1"/>
                 </a:solidFill>
@@ -1695,22 +1656,22 @@
                 <a:ea typeface="Work Sans" pitchFamily="34" charset="-122"/>
                 <a:cs typeface="Work Sans" pitchFamily="34" charset="-120"/>
               </a:rPr>
-              <a:t>Beginner English Tips</a:t>
-            </a:r>
-            <a:endParaRPr lang="en-US" sz="1400" dirty="0"/>
-          </a:p>
-        </p:txBody>
-      </p:sp>
-      <p:sp>
-        <p:nvSpPr>
-          <p:cNvPr id="6" name="Text 4"/>
+              <a:t>MMercedesEnglish  |  Beginner  |  Microclase  |  Asking for repetition</a:t>
+            </a:r>
+            <a:endParaRPr lang="en-US" sz="1100" dirty="0"/>
+          </a:p>
+        </p:txBody>
+      </p:sp>
+      <p:sp>
+        <p:nvSpPr>
+          <p:cNvPr id="5" name="Text 3"/>
           <p:cNvSpPr/>
           <p:nvPr/>
         </p:nvSpPr>
         <p:spPr>
           <a:xfrm>
-            <a:off x="548640" y="6473952"/>
-            <a:ext cx="8229600" cy="292608"/>
+            <a:off x="548640" y="5870448"/>
+            <a:ext cx="1188720" cy="457200"/>
           </a:xfrm>
           <a:prstGeom prst="rect">
             <a:avLst/>
@@ -1726,7 +1687,7 @@
               <a:buNone/>
             </a:pPr>
             <a:r>
-              <a:rPr lang="en-US" sz="1100" dirty="0">
+              <a:rPr lang="en-US" sz="1200" b="1" dirty="0">
                 <a:solidFill>
                   <a:schemeClr val="tx1"/>
                 </a:solidFill>
@@ -1734,45 +1695,6 @@
                 <a:ea typeface="Work Sans" pitchFamily="34" charset="-122"/>
                 <a:cs typeface="Work Sans" pitchFamily="34" charset="-120"/>
               </a:rPr>
-              <a:t>MMercedesEnglish  |  Beginner  |  Microclase  |  Asking for repetition</a:t>
-            </a:r>
-            <a:endParaRPr lang="en-US" sz="1100" dirty="0"/>
-          </a:p>
-        </p:txBody>
-      </p:sp>
-      <p:sp>
-        <p:nvSpPr>
-          <p:cNvPr id="7" name="Text 5"/>
-          <p:cNvSpPr/>
-          <p:nvPr/>
-        </p:nvSpPr>
-        <p:spPr>
-          <a:xfrm>
-            <a:off x="548640" y="5870448"/>
-            <a:ext cx="1188720" cy="457200"/>
-          </a:xfrm>
-          <a:prstGeom prst="rect">
-            <a:avLst/>
-          </a:prstGeom>
-          <a:noFill/>
-          <a:ln/>
-        </p:spPr>
-        <p:txBody>
-          <a:bodyPr wrap="square" lIns="0" tIns="0" rIns="0" bIns="0" rtlCol="0" anchor="ctr"/>
-          <a:lstStyle/>
-          <a:p>
-            <a:pPr indent="0" marL="0">
-              <a:buNone/>
-            </a:pPr>
-            <a:r>
-              <a:rPr lang="en-US" sz="1200" b="1" dirty="0">
-                <a:solidFill>
-                  <a:schemeClr val="tx1"/>
-                </a:solidFill>
-                <a:latin typeface="Work Sans" pitchFamily="34" charset="0"/>
-                <a:ea typeface="Work Sans" pitchFamily="34" charset="-122"/>
-                <a:cs typeface="Work Sans" pitchFamily="34" charset="-120"/>
-              </a:rPr>
               <a:t>MY NOTES</a:t>
             </a:r>
             <a:endParaRPr lang="en-US" sz="1200" dirty="0"/>
@@ -1781,7 +1703,7 @@
       </p:sp>
       <p:sp>
         <p:nvSpPr>
-          <p:cNvPr id="8" name="Shape 6"/>
+          <p:cNvPr id="6" name="Shape 4"/>
           <p:cNvSpPr/>
           <p:nvPr/>
         </p:nvSpPr>
@@ -1804,7 +1726,7 @@
       </p:sp>
       <p:sp>
         <p:nvSpPr>
-          <p:cNvPr id="9" name="Shape 7"/>
+          <p:cNvPr id="7" name="Shape 5"/>
           <p:cNvSpPr/>
           <p:nvPr/>
         </p:nvSpPr>
@@ -1827,10 +1749,10 @@
       </p:sp>
       <p:sp>
         <p:nvSpPr>
-          <p:cNvPr id="10" name="Text 8"/>
+          <p:cNvPr id="8" name="Text 6"/>
           <p:cNvSpPr/>
           <p:nvPr>
-            <p:ph idx="110" type="title" hasCustomPrompt="1"/>
+            <p:ph idx="106" type="title" hasCustomPrompt="1"/>
           </p:nvPr>
         </p:nvSpPr>
         <p:spPr>
@@ -1986,45 +1908,6 @@
         </p:nvSpPr>
         <p:spPr>
           <a:xfrm>
-            <a:off x="457200" y="118872"/>
-            <a:ext cx="548640" cy="548640"/>
-          </a:xfrm>
-          <a:prstGeom prst="rect">
-            <a:avLst/>
-          </a:prstGeom>
-          <a:noFill/>
-          <a:ln/>
-        </p:spPr>
-        <p:txBody>
-          <a:bodyPr wrap="square" lIns="0" tIns="0" rIns="0" bIns="0" rtlCol="0" anchor="ctr"/>
-          <a:lstStyle/>
-          <a:p>
-            <a:pPr algn="ctr" indent="0" marL="0">
-              <a:buNone/>
-            </a:pPr>
-            <a:r>
-              <a:rPr lang="en-US" sz="2000" b="1" dirty="0">
-                <a:solidFill>
-                  <a:schemeClr val="tx1"/>
-                </a:solidFill>
-                <a:latin typeface="Big Shoulders Display" pitchFamily="34" charset="0"/>
-                <a:ea typeface="Big Shoulders Display" pitchFamily="34" charset="-122"/>
-                <a:cs typeface="Big Shoulders Display" pitchFamily="34" charset="-120"/>
-              </a:rPr>
-              <a:t>MM</a:t>
-            </a:r>
-            <a:endParaRPr lang="en-US" sz="2000" dirty="0"/>
-          </a:p>
-        </p:txBody>
-      </p:sp>
-      <p:sp>
-        <p:nvSpPr>
-          <p:cNvPr id="4" name="Text 2"/>
-          <p:cNvSpPr/>
-          <p:nvPr/>
-        </p:nvSpPr>
-        <p:spPr>
-          <a:xfrm>
             <a:off x="1188720" y="118872"/>
             <a:ext cx="4572000" cy="548640"/>
           </a:xfrm>
@@ -2058,14 +1941,14 @@
       </p:sp>
       <p:sp>
         <p:nvSpPr>
-          <p:cNvPr id="5" name="Text 3"/>
+          <p:cNvPr id="4" name="Text 2"/>
           <p:cNvSpPr/>
           <p:nvPr/>
         </p:nvSpPr>
         <p:spPr>
           <a:xfrm>
-            <a:off x="8915400" y="182880"/>
-            <a:ext cx="2743200" cy="411480"/>
+            <a:off x="548640" y="6473952"/>
+            <a:ext cx="8229600" cy="292608"/>
           </a:xfrm>
           <a:prstGeom prst="rect">
             <a:avLst/>
@@ -2077,11 +1960,11 @@
           <a:bodyPr wrap="square" lIns="0" tIns="0" rIns="0" bIns="0" rtlCol="0" anchor="ctr"/>
           <a:lstStyle/>
           <a:p>
-            <a:pPr algn="ctr" indent="0" marL="0">
-              <a:buNone/>
-            </a:pPr>
-            <a:r>
-              <a:rPr lang="en-US" sz="1400" b="1" dirty="0">
+            <a:pPr indent="0" marL="0">
+              <a:buNone/>
+            </a:pPr>
+            <a:r>
+              <a:rPr lang="en-US" sz="1100" dirty="0">
                 <a:solidFill>
                   <a:schemeClr val="tx1"/>
                 </a:solidFill>
@@ -2089,45 +1972,6 @@
                 <a:ea typeface="Work Sans" pitchFamily="34" charset="-122"/>
                 <a:cs typeface="Work Sans" pitchFamily="34" charset="-120"/>
               </a:rPr>
-              <a:t>Beginner English Tips</a:t>
-            </a:r>
-            <a:endParaRPr lang="en-US" sz="1400" dirty="0"/>
-          </a:p>
-        </p:txBody>
-      </p:sp>
-      <p:sp>
-        <p:nvSpPr>
-          <p:cNvPr id="6" name="Text 4"/>
-          <p:cNvSpPr/>
-          <p:nvPr/>
-        </p:nvSpPr>
-        <p:spPr>
-          <a:xfrm>
-            <a:off x="548640" y="6473952"/>
-            <a:ext cx="8229600" cy="292608"/>
-          </a:xfrm>
-          <a:prstGeom prst="rect">
-            <a:avLst/>
-          </a:prstGeom>
-          <a:noFill/>
-          <a:ln/>
-        </p:spPr>
-        <p:txBody>
-          <a:bodyPr wrap="square" lIns="0" tIns="0" rIns="0" bIns="0" rtlCol="0" anchor="ctr"/>
-          <a:lstStyle/>
-          <a:p>
-            <a:pPr indent="0" marL="0">
-              <a:buNone/>
-            </a:pPr>
-            <a:r>
-              <a:rPr lang="en-US" sz="1100" dirty="0">
-                <a:solidFill>
-                  <a:schemeClr val="tx1"/>
-                </a:solidFill>
-                <a:latin typeface="Work Sans" pitchFamily="34" charset="0"/>
-                <a:ea typeface="Work Sans" pitchFamily="34" charset="-122"/>
-                <a:cs typeface="Work Sans" pitchFamily="34" charset="-120"/>
-              </a:rPr>
               <a:t>MMercedesEnglish  |  Beginner  |  Microclase  |  Asking for repetition</a:t>
             </a:r>
             <a:endParaRPr lang="en-US" sz="1100" dirty="0"/>
@@ -2136,10 +1980,10 @@
       </p:sp>
       <p:sp>
         <p:nvSpPr>
-          <p:cNvPr id="7" name="Text 5"/>
+          <p:cNvPr id="5" name="Text 3"/>
           <p:cNvSpPr/>
           <p:nvPr>
-            <p:ph idx="107" type="title" hasCustomPrompt="1"/>
+            <p:ph idx="103" type="title" hasCustomPrompt="1"/>
           </p:nvPr>
         </p:nvSpPr>
         <p:spPr>
@@ -2295,45 +2139,6 @@
         </p:nvSpPr>
         <p:spPr>
           <a:xfrm>
-            <a:off x="457200" y="118872"/>
-            <a:ext cx="548640" cy="548640"/>
-          </a:xfrm>
-          <a:prstGeom prst="rect">
-            <a:avLst/>
-          </a:prstGeom>
-          <a:noFill/>
-          <a:ln/>
-        </p:spPr>
-        <p:txBody>
-          <a:bodyPr wrap="square" lIns="0" tIns="0" rIns="0" bIns="0" rtlCol="0" anchor="ctr"/>
-          <a:lstStyle/>
-          <a:p>
-            <a:pPr algn="ctr" indent="0" marL="0">
-              <a:buNone/>
-            </a:pPr>
-            <a:r>
-              <a:rPr lang="en-US" sz="2000" b="1" dirty="0">
-                <a:solidFill>
-                  <a:schemeClr val="tx1"/>
-                </a:solidFill>
-                <a:latin typeface="Big Shoulders Display" pitchFamily="34" charset="0"/>
-                <a:ea typeface="Big Shoulders Display" pitchFamily="34" charset="-122"/>
-                <a:cs typeface="Big Shoulders Display" pitchFamily="34" charset="-120"/>
-              </a:rPr>
-              <a:t>MM</a:t>
-            </a:r>
-            <a:endParaRPr lang="en-US" sz="2000" dirty="0"/>
-          </a:p>
-        </p:txBody>
-      </p:sp>
-      <p:sp>
-        <p:nvSpPr>
-          <p:cNvPr id="4" name="Text 2"/>
-          <p:cNvSpPr/>
-          <p:nvPr/>
-        </p:nvSpPr>
-        <p:spPr>
-          <a:xfrm>
             <a:off x="1188720" y="118872"/>
             <a:ext cx="4572000" cy="548640"/>
           </a:xfrm>
@@ -2367,46 +2172,7 @@
       </p:sp>
       <p:sp>
         <p:nvSpPr>
-          <p:cNvPr id="5" name="Text 3"/>
-          <p:cNvSpPr/>
-          <p:nvPr/>
-        </p:nvSpPr>
-        <p:spPr>
-          <a:xfrm>
-            <a:off x="8915400" y="182880"/>
-            <a:ext cx="2743200" cy="411480"/>
-          </a:xfrm>
-          <a:prstGeom prst="rect">
-            <a:avLst/>
-          </a:prstGeom>
-          <a:noFill/>
-          <a:ln/>
-        </p:spPr>
-        <p:txBody>
-          <a:bodyPr wrap="square" lIns="0" tIns="0" rIns="0" bIns="0" rtlCol="0" anchor="ctr"/>
-          <a:lstStyle/>
-          <a:p>
-            <a:pPr algn="ctr" indent="0" marL="0">
-              <a:buNone/>
-            </a:pPr>
-            <a:r>
-              <a:rPr lang="en-US" sz="1400" b="1" dirty="0">
-                <a:solidFill>
-                  <a:schemeClr val="tx1"/>
-                </a:solidFill>
-                <a:latin typeface="Work Sans" pitchFamily="34" charset="0"/>
-                <a:ea typeface="Work Sans" pitchFamily="34" charset="-122"/>
-                <a:cs typeface="Work Sans" pitchFamily="34" charset="-120"/>
-              </a:rPr>
-              <a:t>Beginner English Tips</a:t>
-            </a:r>
-            <a:endParaRPr lang="en-US" sz="1400" dirty="0"/>
-          </a:p>
-        </p:txBody>
-      </p:sp>
-      <p:sp>
-        <p:nvSpPr>
-          <p:cNvPr id="6" name="Text 4"/>
+          <p:cNvPr id="4" name="Text 2"/>
           <p:cNvSpPr/>
           <p:nvPr/>
         </p:nvSpPr>
@@ -2846,7 +2612,137 @@
       </p:grpSpPr>
       <p:sp>
         <p:nvSpPr>
-          <p:cNvPr id="2" name="Pastilla microclase"/>
+          <p:cNvPr id="2" name="Logo MM fondo"/>
+          <p:cNvSpPr/>
+          <p:nvPr/>
+        </p:nvSpPr>
+        <p:spPr>
+          <a:xfrm>
+            <a:off x="457200" y="118872"/>
+            <a:ext cx="548640" cy="548640"/>
+          </a:xfrm>
+          <a:prstGeom prst="ellipse">
+            <a:avLst/>
+          </a:prstGeom>
+          <a:solidFill>
+            <a:schemeClr val="accent1"/>
+          </a:solidFill>
+          <a:ln w="12700">
+            <a:solidFill>
+              <a:schemeClr val="accent1"/>
+            </a:solidFill>
+            <a:prstDash val="solid"/>
+          </a:ln>
+        </p:spPr>
+      </p:sp>
+      <p:sp>
+        <p:nvSpPr>
+          <p:cNvPr id="3" name="Logo MM"/>
+          <p:cNvSpPr txBox="1"/>
+          <p:nvPr/>
+        </p:nvSpPr>
+        <p:spPr>
+          <a:xfrm>
+            <a:off x="457200" y="118872"/>
+            <a:ext cx="548640" cy="548640"/>
+          </a:xfrm>
+          <a:prstGeom prst="rect">
+            <a:avLst/>
+          </a:prstGeom>
+          <a:noFill/>
+          <a:ln/>
+        </p:spPr>
+        <p:txBody>
+          <a:bodyPr wrap="square" lIns="0" tIns="0" rIns="0" bIns="0" rtlCol="0" anchor="ctr"/>
+          <a:lstStyle/>
+          <a:p>
+            <a:pPr algn="ctr" indent="0" marL="0">
+              <a:buNone/>
+            </a:pPr>
+            <a:r>
+              <a:rPr lang="en-US" sz="2000" b="1" dirty="0">
+                <a:solidFill>
+                  <a:schemeClr val="tx1"/>
+                </a:solidFill>
+                <a:latin typeface="Big Shoulders Display" pitchFamily="34" charset="0"/>
+                <a:ea typeface="Big Shoulders Display" pitchFamily="34" charset="-122"/>
+                <a:cs typeface="Big Shoulders Display" pitchFamily="34" charset="-120"/>
+              </a:rPr>
+              <a:t>MM</a:t>
+            </a:r>
+            <a:endParaRPr lang="en-US" sz="2000" dirty="0"/>
+          </a:p>
+        </p:txBody>
+      </p:sp>
+      <p:sp>
+        <p:nvSpPr>
+          <p:cNvPr id="4" name="Pastilla nivel"/>
+          <p:cNvSpPr/>
+          <p:nvPr/>
+        </p:nvSpPr>
+        <p:spPr>
+          <a:xfrm>
+            <a:off x="8915400" y="182880"/>
+            <a:ext cx="2743200" cy="411480"/>
+          </a:xfrm>
+          <a:prstGeom prst="roundRect">
+            <a:avLst>
+              <a:gd name="adj" fmla="val 48889"/>
+            </a:avLst>
+          </a:prstGeom>
+          <a:solidFill>
+            <a:schemeClr val="accent1"/>
+          </a:solidFill>
+          <a:ln w="12700">
+            <a:solidFill>
+              <a:schemeClr val="accent1"/>
+            </a:solidFill>
+            <a:prstDash val="solid"/>
+          </a:ln>
+        </p:spPr>
+      </p:sp>
+      <p:sp>
+        <p:nvSpPr>
+          <p:cNvPr id="5" name="Texto pastilla nivel"/>
+          <p:cNvSpPr txBox="1"/>
+          <p:nvPr/>
+        </p:nvSpPr>
+        <p:spPr>
+          <a:xfrm>
+            <a:off x="8915400" y="182880"/>
+            <a:ext cx="2743200" cy="411480"/>
+          </a:xfrm>
+          <a:prstGeom prst="rect">
+            <a:avLst/>
+          </a:prstGeom>
+          <a:noFill/>
+          <a:ln/>
+        </p:spPr>
+        <p:txBody>
+          <a:bodyPr wrap="square" lIns="0" tIns="0" rIns="0" bIns="0" rtlCol="0" anchor="ctr"/>
+          <a:lstStyle/>
+          <a:p>
+            <a:pPr algn="ctr" indent="0" marL="0">
+              <a:buNone/>
+            </a:pPr>
+            <a:r>
+              <a:rPr lang="en-US" sz="1400" b="1" dirty="0">
+                <a:solidFill>
+                  <a:schemeClr val="tx1"/>
+                </a:solidFill>
+                <a:latin typeface="Work Sans" pitchFamily="34" charset="0"/>
+                <a:ea typeface="Work Sans" pitchFamily="34" charset="-122"/>
+                <a:cs typeface="Work Sans" pitchFamily="34" charset="-120"/>
+              </a:rPr>
+              <a:t>Beginner English Tips</a:t>
+            </a:r>
+            <a:endParaRPr lang="en-US" sz="1400" dirty="0"/>
+          </a:p>
+        </p:txBody>
+      </p:sp>
+      <p:sp>
+        <p:nvSpPr>
+          <p:cNvPr id="6" name="Pastilla microclase"/>
           <p:cNvSpPr/>
           <p:nvPr/>
         </p:nvSpPr>
@@ -2873,7 +2769,7 @@
       </p:sp>
       <p:sp>
         <p:nvSpPr>
-          <p:cNvPr id="3" name="Texto pastilla"/>
+          <p:cNvPr id="7" name="Texto pastilla"/>
           <p:cNvSpPr txBox="1"/>
           <p:nvPr/>
         </p:nvSpPr>
@@ -2912,14 +2808,14 @@
       </p:sp>
       <p:sp>
         <p:nvSpPr>
-          <p:cNvPr id="4" name="Título portada"/>
+          <p:cNvPr id="8" name="Título portada"/>
           <p:cNvSpPr txBox="1"/>
           <p:nvPr/>
         </p:nvSpPr>
         <p:spPr>
           <a:xfrm>
             <a:off x="548640" y="1783080"/>
-            <a:ext cx="7223760" cy="2560320"/>
+            <a:ext cx="7040880" cy="2560320"/>
           </a:xfrm>
           <a:prstGeom prst="rect">
             <a:avLst/>
@@ -2951,7 +2847,7 @@
       </p:sp>
       <p:sp>
         <p:nvSpPr>
-          <p:cNvPr id="5" name="Subtítulo portada"/>
+          <p:cNvPr id="9" name="Subtítulo portada"/>
           <p:cNvSpPr txBox="1"/>
           <p:nvPr/>
         </p:nvSpPr>
@@ -2990,7 +2886,7 @@
       </p:sp>
       <p:sp>
         <p:nvSpPr>
-          <p:cNvPr id="6" name="Lema"/>
+          <p:cNvPr id="10" name="Lema"/>
           <p:cNvSpPr/>
           <p:nvPr/>
         </p:nvSpPr>
@@ -3017,7 +2913,7 @@
       </p:sp>
       <p:sp>
         <p:nvSpPr>
-          <p:cNvPr id="7" name="Texto lema"/>
+          <p:cNvPr id="11" name="Texto lema"/>
           <p:cNvSpPr txBox="1"/>
           <p:nvPr/>
         </p:nvSpPr>
@@ -3056,18 +2952,18 @@
       </p:sp>
       <p:sp>
         <p:nvSpPr>
-          <p:cNvPr id="8" name="Marco avatar"/>
+          <p:cNvPr id="12" name="Marco avatar"/>
           <p:cNvSpPr/>
           <p:nvPr/>
         </p:nvSpPr>
         <p:spPr>
           <a:xfrm>
-            <a:off x="8412480" y="1051560"/>
-            <a:ext cx="4171086" cy="5166360"/>
+            <a:off x="7799832" y="1051560"/>
+            <a:ext cx="3841784" cy="4754880"/>
           </a:xfrm>
           <a:prstGeom prst="roundRect">
             <a:avLst>
-              <a:gd name="adj" fmla="val 2631"/>
+              <a:gd name="adj" fmla="val 2856"/>
             </a:avLst>
           </a:prstGeom>
           <a:solidFill>
@@ -3083,7 +2979,7 @@
       </p:sp>
       <p:pic>
         <p:nvPicPr>
-          <p:cNvPr id="9" name="Avatar Mercedes" descr="Mercedes, profesora de MMercedesEnglish">    </p:cNvPr>
+          <p:cNvPr id="13" name="Avatar Mercedes" descr="Mercedes, profesora de MMercedesEnglish">    </p:cNvPr>
           <p:cNvPicPr>
             <a:picLocks noChangeAspect="1"/>
           </p:cNvPicPr>
@@ -3097,8 +2993,8 @@
         </p:blipFill>
         <p:spPr>
           <a:xfrm>
-            <a:off x="8503920" y="1143000"/>
-            <a:ext cx="3988206" cy="4983480"/>
+            <a:off x="7891272" y="1143000"/>
+            <a:ext cx="3658904" cy="4572000"/>
           </a:xfrm>
           <a:prstGeom prst="rect">
             <a:avLst/>
@@ -3180,16 +3076,39 @@
       </p:grpSpPr>
       <p:sp>
         <p:nvSpPr>
-          <p:cNvPr id="2" name="Text 8"/>
+          <p:cNvPr id="2" name="Logo MM fondo"/>
           <p:cNvSpPr/>
-          <p:nvPr>
-            <p:ph idx="110" type="title" hasCustomPrompt="1"/>
-          </p:nvPr>
-        </p:nvSpPr>
-        <p:spPr>
-          <a:xfrm>
-            <a:off x="548640" y="914400"/>
-            <a:ext cx="11064240" cy="822960"/>
+          <p:nvPr/>
+        </p:nvSpPr>
+        <p:spPr>
+          <a:xfrm>
+            <a:off x="457200" y="118872"/>
+            <a:ext cx="548640" cy="548640"/>
+          </a:xfrm>
+          <a:prstGeom prst="ellipse">
+            <a:avLst/>
+          </a:prstGeom>
+          <a:solidFill>
+            <a:schemeClr val="accent1"/>
+          </a:solidFill>
+          <a:ln w="12700">
+            <a:solidFill>
+              <a:schemeClr val="accent1"/>
+            </a:solidFill>
+            <a:prstDash val="solid"/>
+          </a:ln>
+        </p:spPr>
+      </p:sp>
+      <p:sp>
+        <p:nvSpPr>
+          <p:cNvPr id="3" name="Logo MM"/>
+          <p:cNvSpPr txBox="1"/>
+          <p:nvPr/>
+        </p:nvSpPr>
+        <p:spPr>
+          <a:xfrm>
+            <a:off x="457200" y="118872"/>
+            <a:ext cx="548640" cy="548640"/>
           </a:xfrm>
           <a:prstGeom prst="rect">
             <a:avLst/>
@@ -3201,11 +3120,11 @@
           <a:bodyPr wrap="square" lIns="0" tIns="0" rIns="0" bIns="0" rtlCol="0" anchor="ctr"/>
           <a:lstStyle/>
           <a:p>
-            <a:pPr algn="l" indent="0" marL="0">
-              <a:buNone/>
-            </a:pPr>
-            <a:r>
-              <a:rPr lang="en-US" sz="3600" b="1" dirty="0">
+            <a:pPr algn="ctr" indent="0" marL="0">
+              <a:buNone/>
+            </a:pPr>
+            <a:r>
+              <a:rPr lang="en-US" sz="2000" b="1" dirty="0">
                 <a:solidFill>
                   <a:schemeClr val="tx1"/>
                 </a:solidFill>
@@ -3213,6 +3132,113 @@
                 <a:ea typeface="Big Shoulders Display" pitchFamily="34" charset="-122"/>
                 <a:cs typeface="Big Shoulders Display" pitchFamily="34" charset="-120"/>
               </a:rPr>
+              <a:t>MM</a:t>
+            </a:r>
+            <a:endParaRPr lang="en-US" sz="2000" dirty="0"/>
+          </a:p>
+        </p:txBody>
+      </p:sp>
+      <p:sp>
+        <p:nvSpPr>
+          <p:cNvPr id="4" name="Pastilla nivel"/>
+          <p:cNvSpPr/>
+          <p:nvPr/>
+        </p:nvSpPr>
+        <p:spPr>
+          <a:xfrm>
+            <a:off x="8915400" y="182880"/>
+            <a:ext cx="2743200" cy="411480"/>
+          </a:xfrm>
+          <a:prstGeom prst="roundRect">
+            <a:avLst>
+              <a:gd name="adj" fmla="val 48889"/>
+            </a:avLst>
+          </a:prstGeom>
+          <a:solidFill>
+            <a:schemeClr val="accent1"/>
+          </a:solidFill>
+          <a:ln w="12700">
+            <a:solidFill>
+              <a:schemeClr val="accent1"/>
+            </a:solidFill>
+            <a:prstDash val="solid"/>
+          </a:ln>
+        </p:spPr>
+      </p:sp>
+      <p:sp>
+        <p:nvSpPr>
+          <p:cNvPr id="5" name="Texto pastilla nivel"/>
+          <p:cNvSpPr txBox="1"/>
+          <p:nvPr/>
+        </p:nvSpPr>
+        <p:spPr>
+          <a:xfrm>
+            <a:off x="8915400" y="182880"/>
+            <a:ext cx="2743200" cy="411480"/>
+          </a:xfrm>
+          <a:prstGeom prst="rect">
+            <a:avLst/>
+          </a:prstGeom>
+          <a:noFill/>
+          <a:ln/>
+        </p:spPr>
+        <p:txBody>
+          <a:bodyPr wrap="square" lIns="0" tIns="0" rIns="0" bIns="0" rtlCol="0" anchor="ctr"/>
+          <a:lstStyle/>
+          <a:p>
+            <a:pPr algn="ctr" indent="0" marL="0">
+              <a:buNone/>
+            </a:pPr>
+            <a:r>
+              <a:rPr lang="en-US" sz="1400" b="1" dirty="0">
+                <a:solidFill>
+                  <a:schemeClr val="tx1"/>
+                </a:solidFill>
+                <a:latin typeface="Work Sans" pitchFamily="34" charset="0"/>
+                <a:ea typeface="Work Sans" pitchFamily="34" charset="-122"/>
+                <a:cs typeface="Work Sans" pitchFamily="34" charset="-120"/>
+              </a:rPr>
+              <a:t>Beginner English Tips</a:t>
+            </a:r>
+            <a:endParaRPr lang="en-US" sz="1400" dirty="0"/>
+          </a:p>
+        </p:txBody>
+      </p:sp>
+      <p:sp>
+        <p:nvSpPr>
+          <p:cNvPr id="6" name="Text 6"/>
+          <p:cNvSpPr/>
+          <p:nvPr>
+            <p:ph idx="106" type="title" hasCustomPrompt="1"/>
+          </p:nvPr>
+        </p:nvSpPr>
+        <p:spPr>
+          <a:xfrm>
+            <a:off x="548640" y="914400"/>
+            <a:ext cx="11064240" cy="822960"/>
+          </a:xfrm>
+          <a:prstGeom prst="rect">
+            <a:avLst/>
+          </a:prstGeom>
+          <a:noFill/>
+          <a:ln/>
+        </p:spPr>
+        <p:txBody>
+          <a:bodyPr wrap="square" lIns="0" tIns="0" rIns="0" bIns="0" rtlCol="0" anchor="ctr"/>
+          <a:lstStyle/>
+          <a:p>
+            <a:pPr algn="l" indent="0" marL="0">
+              <a:buNone/>
+            </a:pPr>
+            <a:r>
+              <a:rPr lang="en-US" sz="3600" b="1" dirty="0">
+                <a:solidFill>
+                  <a:schemeClr val="tx1"/>
+                </a:solidFill>
+                <a:latin typeface="Big Shoulders Display" pitchFamily="34" charset="0"/>
+                <a:ea typeface="Big Shoulders Display" pitchFamily="34" charset="-122"/>
+                <a:cs typeface="Big Shoulders Display" pitchFamily="34" charset="-120"/>
+              </a:rPr>
               <a:t>COMPROBACIÓN: RESPUESTA</a:t>
             </a:r>
             <a:endParaRPr lang="en-US" sz="3600" dirty="0"/>
@@ -3221,7 +3247,7 @@
       </p:sp>
       <p:sp>
         <p:nvSpPr>
-          <p:cNvPr id="3" name="Tarjeta dato"/>
+          <p:cNvPr id="7" name="Tarjeta dato"/>
           <p:cNvSpPr/>
           <p:nvPr/>
         </p:nvSpPr>
@@ -3248,7 +3274,7 @@
       </p:sp>
       <p:pic>
         <p:nvPicPr>
-          <p:cNvPr id="4" name="Ícono hiking" descr="Caminata">    </p:cNvPr>
+          <p:cNvPr id="8" name="Ícono hiking" descr="Caminata">    </p:cNvPr>
           <p:cNvPicPr>
             <a:picLocks noChangeAspect="1"/>
           </p:cNvPicPr>
@@ -3272,7 +3298,7 @@
       </p:pic>
       <p:sp>
         <p:nvSpPr>
-          <p:cNvPr id="5" name="Dato"/>
+          <p:cNvPr id="9" name="Dato"/>
           <p:cNvSpPr txBox="1"/>
           <p:nvPr/>
         </p:nvSpPr>
@@ -3334,7 +3360,7 @@
       </p:sp>
       <p:sp>
         <p:nvSpPr>
-          <p:cNvPr id="6" name="Tarjeta respuesta"/>
+          <p:cNvPr id="10" name="Tarjeta respuesta"/>
           <p:cNvSpPr/>
           <p:nvPr/>
         </p:nvSpPr>
@@ -3361,7 +3387,7 @@
       </p:sp>
       <p:pic>
         <p:nvPicPr>
-          <p:cNvPr id="7" name="Ícono check" descr="Correcto">    </p:cNvPr>
+          <p:cNvPr id="11" name="Ícono check" descr="Correcto">    </p:cNvPr>
           <p:cNvPicPr>
             <a:picLocks noChangeAspect="1"/>
           </p:cNvPicPr>
@@ -3385,7 +3411,7 @@
       </p:pic>
       <p:sp>
         <p:nvSpPr>
-          <p:cNvPr id="8" name="Respuesta"/>
+          <p:cNvPr id="12" name="Respuesta"/>
           <p:cNvSpPr txBox="1"/>
           <p:nvPr/>
         </p:nvSpPr>
@@ -3520,16 +3546,39 @@
       </p:grpSpPr>
       <p:sp>
         <p:nvSpPr>
-          <p:cNvPr id="2" name="Text 5"/>
+          <p:cNvPr id="2" name="Logo MM fondo"/>
           <p:cNvSpPr/>
-          <p:nvPr>
-            <p:ph idx="107" type="title" hasCustomPrompt="1"/>
-          </p:nvPr>
-        </p:nvSpPr>
-        <p:spPr>
-          <a:xfrm>
-            <a:off x="548640" y="914400"/>
-            <a:ext cx="11064240" cy="822960"/>
+          <p:nvPr/>
+        </p:nvSpPr>
+        <p:spPr>
+          <a:xfrm>
+            <a:off x="457200" y="118872"/>
+            <a:ext cx="548640" cy="548640"/>
+          </a:xfrm>
+          <a:prstGeom prst="ellipse">
+            <a:avLst/>
+          </a:prstGeom>
+          <a:solidFill>
+            <a:schemeClr val="accent1"/>
+          </a:solidFill>
+          <a:ln w="12700">
+            <a:solidFill>
+              <a:schemeClr val="accent1"/>
+            </a:solidFill>
+            <a:prstDash val="solid"/>
+          </a:ln>
+        </p:spPr>
+      </p:sp>
+      <p:sp>
+        <p:nvSpPr>
+          <p:cNvPr id="3" name="Logo MM"/>
+          <p:cNvSpPr txBox="1"/>
+          <p:nvPr/>
+        </p:nvSpPr>
+        <p:spPr>
+          <a:xfrm>
+            <a:off x="457200" y="118872"/>
+            <a:ext cx="548640" cy="548640"/>
           </a:xfrm>
           <a:prstGeom prst="rect">
             <a:avLst/>
@@ -3541,11 +3590,11 @@
           <a:bodyPr wrap="square" lIns="0" tIns="0" rIns="0" bIns="0" rtlCol="0" anchor="ctr"/>
           <a:lstStyle/>
           <a:p>
-            <a:pPr algn="l" indent="0" marL="0">
-              <a:buNone/>
-            </a:pPr>
-            <a:r>
-              <a:rPr lang="en-US" sz="3600" b="1" dirty="0">
+            <a:pPr algn="ctr" indent="0" marL="0">
+              <a:buNone/>
+            </a:pPr>
+            <a:r>
+              <a:rPr lang="en-US" sz="2000" b="1" dirty="0">
                 <a:solidFill>
                   <a:schemeClr val="tx1"/>
                 </a:solidFill>
@@ -3553,6 +3602,113 @@
                 <a:ea typeface="Big Shoulders Display" pitchFamily="34" charset="-122"/>
                 <a:cs typeface="Big Shoulders Display" pitchFamily="34" charset="-120"/>
               </a:rPr>
+              <a:t>MM</a:t>
+            </a:r>
+            <a:endParaRPr lang="en-US" sz="2000" dirty="0"/>
+          </a:p>
+        </p:txBody>
+      </p:sp>
+      <p:sp>
+        <p:nvSpPr>
+          <p:cNvPr id="4" name="Pastilla nivel"/>
+          <p:cNvSpPr/>
+          <p:nvPr/>
+        </p:nvSpPr>
+        <p:spPr>
+          <a:xfrm>
+            <a:off x="8915400" y="182880"/>
+            <a:ext cx="2743200" cy="411480"/>
+          </a:xfrm>
+          <a:prstGeom prst="roundRect">
+            <a:avLst>
+              <a:gd name="adj" fmla="val 48889"/>
+            </a:avLst>
+          </a:prstGeom>
+          <a:solidFill>
+            <a:schemeClr val="accent1"/>
+          </a:solidFill>
+          <a:ln w="12700">
+            <a:solidFill>
+              <a:schemeClr val="accent1"/>
+            </a:solidFill>
+            <a:prstDash val="solid"/>
+          </a:ln>
+        </p:spPr>
+      </p:sp>
+      <p:sp>
+        <p:nvSpPr>
+          <p:cNvPr id="5" name="Texto pastilla nivel"/>
+          <p:cNvSpPr txBox="1"/>
+          <p:nvPr/>
+        </p:nvSpPr>
+        <p:spPr>
+          <a:xfrm>
+            <a:off x="8915400" y="182880"/>
+            <a:ext cx="2743200" cy="411480"/>
+          </a:xfrm>
+          <a:prstGeom prst="rect">
+            <a:avLst/>
+          </a:prstGeom>
+          <a:noFill/>
+          <a:ln/>
+        </p:spPr>
+        <p:txBody>
+          <a:bodyPr wrap="square" lIns="0" tIns="0" rIns="0" bIns="0" rtlCol="0" anchor="ctr"/>
+          <a:lstStyle/>
+          <a:p>
+            <a:pPr algn="ctr" indent="0" marL="0">
+              <a:buNone/>
+            </a:pPr>
+            <a:r>
+              <a:rPr lang="en-US" sz="1400" b="1" dirty="0">
+                <a:solidFill>
+                  <a:schemeClr val="tx1"/>
+                </a:solidFill>
+                <a:latin typeface="Work Sans" pitchFamily="34" charset="0"/>
+                <a:ea typeface="Work Sans" pitchFamily="34" charset="-122"/>
+                <a:cs typeface="Work Sans" pitchFamily="34" charset="-120"/>
+              </a:rPr>
+              <a:t>Beginner English Tips</a:t>
+            </a:r>
+            <a:endParaRPr lang="en-US" sz="1400" dirty="0"/>
+          </a:p>
+        </p:txBody>
+      </p:sp>
+      <p:sp>
+        <p:nvSpPr>
+          <p:cNvPr id="6" name="Text 3"/>
+          <p:cNvSpPr/>
+          <p:nvPr>
+            <p:ph idx="103" type="title" hasCustomPrompt="1"/>
+          </p:nvPr>
+        </p:nvSpPr>
+        <p:spPr>
+          <a:xfrm>
+            <a:off x="548640" y="914400"/>
+            <a:ext cx="11064240" cy="822960"/>
+          </a:xfrm>
+          <a:prstGeom prst="rect">
+            <a:avLst/>
+          </a:prstGeom>
+          <a:noFill/>
+          <a:ln/>
+        </p:spPr>
+        <p:txBody>
+          <a:bodyPr wrap="square" lIns="0" tIns="0" rIns="0" bIns="0" rtlCol="0" anchor="ctr"/>
+          <a:lstStyle/>
+          <a:p>
+            <a:pPr algn="l" indent="0" marL="0">
+              <a:buNone/>
+            </a:pPr>
+            <a:r>
+              <a:rPr lang="en-US" sz="3600" b="1" dirty="0">
+                <a:solidFill>
+                  <a:schemeClr val="tx1"/>
+                </a:solidFill>
+                <a:latin typeface="Big Shoulders Display" pitchFamily="34" charset="0"/>
+                <a:ea typeface="Big Shoulders Display" pitchFamily="34" charset="-122"/>
+                <a:cs typeface="Big Shoulders Display" pitchFamily="34" charset="-120"/>
+              </a:rPr>
               <a:t>DOS FORMAS CORTESES</a:t>
             </a:r>
             <a:endParaRPr lang="en-US" sz="3600" dirty="0"/>
@@ -3561,7 +3717,7 @@
       </p:sp>
       <p:sp>
         <p:nvSpPr>
-          <p:cNvPr id="3" name="Expresiones"/>
+          <p:cNvPr id="7" name="Expresiones"/>
           <p:cNvSpPr/>
           <p:nvPr/>
         </p:nvSpPr>
@@ -3588,7 +3744,7 @@
       </p:sp>
       <p:sp>
         <p:nvSpPr>
-          <p:cNvPr id="4" name="Frases"/>
+          <p:cNvPr id="8" name="Frases"/>
           <p:cNvSpPr txBox="1"/>
           <p:nvPr/>
         </p:nvSpPr>
@@ -3650,7 +3806,7 @@
       </p:sp>
       <p:sp>
         <p:nvSpPr>
-          <p:cNvPr id="5" name="Dos pasos"/>
+          <p:cNvPr id="9" name="Dos pasos"/>
           <p:cNvSpPr/>
           <p:nvPr/>
         </p:nvSpPr>
@@ -3677,14 +3833,14 @@
       </p:sp>
       <p:sp>
         <p:nvSpPr>
-          <p:cNvPr id="6" name="Pasos"/>
+          <p:cNvPr id="10" name="Paso 1"/>
           <p:cNvSpPr txBox="1"/>
           <p:nvPr/>
         </p:nvSpPr>
         <p:spPr>
           <a:xfrm>
             <a:off x="868680" y="3657600"/>
-            <a:ext cx="7223760" cy="868680"/>
+            <a:ext cx="3566160" cy="868680"/>
           </a:xfrm>
           <a:prstGeom prst="rect">
             <a:avLst/>
@@ -3708,7 +3864,7 @@
                 <a:ea typeface="Work Sans" pitchFamily="34" charset="-122"/>
                 <a:cs typeface="Work Sans" pitchFamily="34" charset="-120"/>
               </a:rPr>
-              <a:t>1. Pide que repitan.   2. Responde al dato.</a:t>
+              <a:t>1. Pide que repitan</a:t>
             </a:r>
             <a:endParaRPr lang="en-US" sz="2400" dirty="0"/>
           </a:p>
@@ -3716,7 +3872,46 @@
       </p:sp>
       <p:sp>
         <p:nvSpPr>
-          <p:cNvPr id="7" name="Pregunta de salida"/>
+          <p:cNvPr id="11" name="Paso 2"/>
+          <p:cNvSpPr txBox="1"/>
+          <p:nvPr/>
+        </p:nvSpPr>
+        <p:spPr>
+          <a:xfrm>
+            <a:off x="4572000" y="3657600"/>
+            <a:ext cx="3566160" cy="868680"/>
+          </a:xfrm>
+          <a:prstGeom prst="rect">
+            <a:avLst/>
+          </a:prstGeom>
+          <a:noFill/>
+          <a:ln/>
+        </p:spPr>
+        <p:txBody>
+          <a:bodyPr wrap="square" lIns="0" tIns="0" rIns="0" bIns="0" rtlCol="0" anchor="ctr"/>
+          <a:lstStyle/>
+          <a:p>
+            <a:pPr indent="0" marL="0">
+              <a:buNone/>
+            </a:pPr>
+            <a:r>
+              <a:rPr lang="en-US" sz="2400" b="1" dirty="0">
+                <a:solidFill>
+                  <a:schemeClr val="bg1"/>
+                </a:solidFill>
+                <a:latin typeface="Work Sans" pitchFamily="34" charset="0"/>
+                <a:ea typeface="Work Sans" pitchFamily="34" charset="-122"/>
+                <a:cs typeface="Work Sans" pitchFamily="34" charset="-120"/>
+              </a:rPr>
+              <a:t>2. Responde al dato</a:t>
+            </a:r>
+            <a:endParaRPr lang="en-US" sz="2400" dirty="0"/>
+          </a:p>
+        </p:txBody>
+      </p:sp>
+      <p:sp>
+        <p:nvSpPr>
+          <p:cNvPr id="12" name="Pregunta de salida"/>
           <p:cNvSpPr/>
           <p:nvPr/>
         </p:nvSpPr>
@@ -3743,7 +3938,7 @@
       </p:sp>
       <p:sp>
         <p:nvSpPr>
-          <p:cNvPr id="8" name="Pregunta"/>
+          <p:cNvPr id="13" name="Pregunta"/>
           <p:cNvSpPr txBox="1"/>
           <p:nvPr/>
         </p:nvSpPr>
@@ -3805,18 +4000,18 @@
       </p:sp>
       <p:sp>
         <p:nvSpPr>
-          <p:cNvPr id="9" name="Marco avatar"/>
+          <p:cNvPr id="14" name="Marco avatar"/>
           <p:cNvSpPr/>
           <p:nvPr/>
         </p:nvSpPr>
         <p:spPr>
           <a:xfrm>
-            <a:off x="8823960" y="1874520"/>
-            <a:ext cx="3183182" cy="3931920"/>
+            <a:off x="8686800" y="1874520"/>
+            <a:ext cx="2963647" cy="3657600"/>
           </a:xfrm>
           <a:prstGeom prst="roundRect">
             <a:avLst>
-              <a:gd name="adj" fmla="val 3447"/>
+              <a:gd name="adj" fmla="val 3702"/>
             </a:avLst>
           </a:prstGeom>
           <a:solidFill>
@@ -3832,7 +4027,7 @@
       </p:sp>
       <p:pic>
         <p:nvPicPr>
-          <p:cNvPr id="10" name="Avatar Mercedes" descr="Mercedes, profesora de MMercedesEnglish">    </p:cNvPr>
+          <p:cNvPr id="15" name="Avatar Mercedes" descr="Mercedes, profesora de MMercedesEnglish">    </p:cNvPr>
           <p:cNvPicPr>
             <a:picLocks noChangeAspect="1"/>
           </p:cNvPicPr>
@@ -3846,8 +4041,8 @@
         </p:blipFill>
         <p:spPr>
           <a:xfrm>
-            <a:off x="8915400" y="1965960"/>
-            <a:ext cx="3000302" cy="3749040"/>
+            <a:off x="8778240" y="1965960"/>
+            <a:ext cx="2780767" cy="3474720"/>
           </a:xfrm>
           <a:prstGeom prst="rect">
             <a:avLst/>
@@ -3929,16 +4124,39 @@
       </p:grpSpPr>
       <p:sp>
         <p:nvSpPr>
-          <p:cNvPr id="2" name="Text 8"/>
+          <p:cNvPr id="2" name="Logo MM fondo"/>
           <p:cNvSpPr/>
-          <p:nvPr>
-            <p:ph idx="110" type="title" hasCustomPrompt="1"/>
-          </p:nvPr>
-        </p:nvSpPr>
-        <p:spPr>
-          <a:xfrm>
-            <a:off x="548640" y="914400"/>
-            <a:ext cx="11064240" cy="822960"/>
+          <p:nvPr/>
+        </p:nvSpPr>
+        <p:spPr>
+          <a:xfrm>
+            <a:off x="457200" y="118872"/>
+            <a:ext cx="548640" cy="548640"/>
+          </a:xfrm>
+          <a:prstGeom prst="ellipse">
+            <a:avLst/>
+          </a:prstGeom>
+          <a:solidFill>
+            <a:schemeClr val="accent1"/>
+          </a:solidFill>
+          <a:ln w="12700">
+            <a:solidFill>
+              <a:schemeClr val="accent1"/>
+            </a:solidFill>
+            <a:prstDash val="solid"/>
+          </a:ln>
+        </p:spPr>
+      </p:sp>
+      <p:sp>
+        <p:nvSpPr>
+          <p:cNvPr id="3" name="Logo MM"/>
+          <p:cNvSpPr txBox="1"/>
+          <p:nvPr/>
+        </p:nvSpPr>
+        <p:spPr>
+          <a:xfrm>
+            <a:off x="457200" y="118872"/>
+            <a:ext cx="548640" cy="548640"/>
           </a:xfrm>
           <a:prstGeom prst="rect">
             <a:avLst/>
@@ -3950,11 +4168,11 @@
           <a:bodyPr wrap="square" lIns="0" tIns="0" rIns="0" bIns="0" rtlCol="0" anchor="ctr"/>
           <a:lstStyle/>
           <a:p>
-            <a:pPr algn="l" indent="0" marL="0">
-              <a:buNone/>
-            </a:pPr>
-            <a:r>
-              <a:rPr lang="en-US" sz="3600" b="1" dirty="0">
+            <a:pPr algn="ctr" indent="0" marL="0">
+              <a:buNone/>
+            </a:pPr>
+            <a:r>
+              <a:rPr lang="en-US" sz="2000" b="1" dirty="0">
                 <a:solidFill>
                   <a:schemeClr val="tx1"/>
                 </a:solidFill>
@@ -3962,6 +4180,113 @@
                 <a:ea typeface="Big Shoulders Display" pitchFamily="34" charset="-122"/>
                 <a:cs typeface="Big Shoulders Display" pitchFamily="34" charset="-120"/>
               </a:rPr>
+              <a:t>MM</a:t>
+            </a:r>
+            <a:endParaRPr lang="en-US" sz="2000" dirty="0"/>
+          </a:p>
+        </p:txBody>
+      </p:sp>
+      <p:sp>
+        <p:nvSpPr>
+          <p:cNvPr id="4" name="Pastilla nivel"/>
+          <p:cNvSpPr/>
+          <p:nvPr/>
+        </p:nvSpPr>
+        <p:spPr>
+          <a:xfrm>
+            <a:off x="8915400" y="182880"/>
+            <a:ext cx="2743200" cy="411480"/>
+          </a:xfrm>
+          <a:prstGeom prst="roundRect">
+            <a:avLst>
+              <a:gd name="adj" fmla="val 48889"/>
+            </a:avLst>
+          </a:prstGeom>
+          <a:solidFill>
+            <a:schemeClr val="accent1"/>
+          </a:solidFill>
+          <a:ln w="12700">
+            <a:solidFill>
+              <a:schemeClr val="accent1"/>
+            </a:solidFill>
+            <a:prstDash val="solid"/>
+          </a:ln>
+        </p:spPr>
+      </p:sp>
+      <p:sp>
+        <p:nvSpPr>
+          <p:cNvPr id="5" name="Texto pastilla nivel"/>
+          <p:cNvSpPr txBox="1"/>
+          <p:nvPr/>
+        </p:nvSpPr>
+        <p:spPr>
+          <a:xfrm>
+            <a:off x="8915400" y="182880"/>
+            <a:ext cx="2743200" cy="411480"/>
+          </a:xfrm>
+          <a:prstGeom prst="rect">
+            <a:avLst/>
+          </a:prstGeom>
+          <a:noFill/>
+          <a:ln/>
+        </p:spPr>
+        <p:txBody>
+          <a:bodyPr wrap="square" lIns="0" tIns="0" rIns="0" bIns="0" rtlCol="0" anchor="ctr"/>
+          <a:lstStyle/>
+          <a:p>
+            <a:pPr algn="ctr" indent="0" marL="0">
+              <a:buNone/>
+            </a:pPr>
+            <a:r>
+              <a:rPr lang="en-US" sz="1400" b="1" dirty="0">
+                <a:solidFill>
+                  <a:schemeClr val="tx1"/>
+                </a:solidFill>
+                <a:latin typeface="Work Sans" pitchFamily="34" charset="0"/>
+                <a:ea typeface="Work Sans" pitchFamily="34" charset="-122"/>
+                <a:cs typeface="Work Sans" pitchFamily="34" charset="-120"/>
+              </a:rPr>
+              <a:t>Beginner English Tips</a:t>
+            </a:r>
+            <a:endParaRPr lang="en-US" sz="1400" dirty="0"/>
+          </a:p>
+        </p:txBody>
+      </p:sp>
+      <p:sp>
+        <p:nvSpPr>
+          <p:cNvPr id="6" name="Text 6"/>
+          <p:cNvSpPr/>
+          <p:nvPr>
+            <p:ph idx="106" type="title" hasCustomPrompt="1"/>
+          </p:nvPr>
+        </p:nvSpPr>
+        <p:spPr>
+          <a:xfrm>
+            <a:off x="548640" y="914400"/>
+            <a:ext cx="11064240" cy="822960"/>
+          </a:xfrm>
+          <a:prstGeom prst="rect">
+            <a:avLst/>
+          </a:prstGeom>
+          <a:noFill/>
+          <a:ln/>
+        </p:spPr>
+        <p:txBody>
+          <a:bodyPr wrap="square" lIns="0" tIns="0" rIns="0" bIns="0" rtlCol="0" anchor="ctr"/>
+          <a:lstStyle/>
+          <a:p>
+            <a:pPr algn="l" indent="0" marL="0">
+              <a:buNone/>
+            </a:pPr>
+            <a:r>
+              <a:rPr lang="en-US" sz="3600" b="1" dirty="0">
+                <a:solidFill>
+                  <a:schemeClr val="tx1"/>
+                </a:solidFill>
+                <a:latin typeface="Big Shoulders Display" pitchFamily="34" charset="0"/>
+                <a:ea typeface="Big Shoulders Display" pitchFamily="34" charset="-122"/>
+                <a:cs typeface="Big Shoulders Display" pitchFamily="34" charset="-120"/>
+              </a:rPr>
               <a:t>¿ESCUCHASTE LA OCUPACIÓN?</a:t>
             </a:r>
             <a:endParaRPr lang="en-US" sz="3600" dirty="0"/>
@@ -3970,7 +4295,7 @@
       </p:sp>
       <p:sp>
         <p:nvSpPr>
-          <p:cNvPr id="3" name="Tarjeta diálogo"/>
+          <p:cNvPr id="7" name="Tarjeta diálogo"/>
           <p:cNvSpPr/>
           <p:nvPr/>
         </p:nvSpPr>
@@ -3997,7 +4322,7 @@
       </p:sp>
       <p:sp>
         <p:nvSpPr>
-          <p:cNvPr id="4" name="Etiqueta diálogo"/>
+          <p:cNvPr id="8" name="Etiqueta diálogo"/>
           <p:cNvSpPr txBox="1"/>
           <p:nvPr/>
         </p:nvSpPr>
@@ -4036,7 +4361,7 @@
       </p:sp>
       <p:pic>
         <p:nvPicPr>
-          <p:cNvPr id="5" name="Ícono audio" descr="Altavoz">    </p:cNvPr>
+          <p:cNvPr id="9" name="Ícono audio" descr="Altavoz">    </p:cNvPr>
           <p:cNvPicPr>
             <a:picLocks noChangeAspect="1"/>
           </p:cNvPicPr>
@@ -4060,13 +4385,13 @@
       </p:pic>
       <p:sp>
         <p:nvSpPr>
-          <p:cNvPr id="6" name="Diálogo"/>
+          <p:cNvPr id="10" name="Diálogo"/>
           <p:cNvSpPr txBox="1"/>
           <p:nvPr/>
         </p:nvSpPr>
         <p:spPr>
           <a:xfrm>
-            <a:off x="868680" y="2651760"/>
+            <a:off x="868680" y="2743200"/>
             <a:ext cx="5943600" cy="2560320"/>
           </a:xfrm>
           <a:prstGeom prst="rect">
@@ -4081,12 +4406,12 @@
           <a:p>
             <a:pPr indent="0" marL="0">
               <a:spcAft>
-                <a:spcPts val="1800"/>
+                <a:spcPts val="2600"/>
               </a:spcAft>
               <a:buNone/>
             </a:pPr>
             <a:r>
-              <a:rPr lang="en-US" sz="3000" b="1" dirty="0">
+              <a:rPr lang="en-US" sz="3400" b="1" dirty="0">
                 <a:solidFill>
                   <a:schemeClr val="tx1"/>
                 </a:solidFill>
@@ -4098,12 +4423,12 @@
             </a:r>
             <a:pPr indent="0" marL="0">
               <a:spcAft>
-                <a:spcPts val="1800"/>
+                <a:spcPts val="2600"/>
               </a:spcAft>
               <a:buNone/>
             </a:pPr>
             <a:r>
-              <a:rPr lang="en-US" sz="3000" i="1" dirty="0">
+              <a:rPr lang="en-US" sz="3400" i="1" dirty="0">
                 <a:solidFill>
                   <a:schemeClr val="tx1"/>
                 </a:solidFill>
@@ -4118,12 +4443,12 @@
           <a:p>
             <a:pPr indent="0" marL="0">
               <a:spcAft>
-                <a:spcPts val="1800"/>
+                <a:spcPts val="2600"/>
               </a:spcAft>
               <a:buNone/>
             </a:pPr>
             <a:r>
-              <a:rPr lang="en-US" sz="3000" b="1" dirty="0">
+              <a:rPr lang="en-US" sz="3400" b="1" dirty="0">
                 <a:solidFill>
                   <a:schemeClr val="tx1"/>
                 </a:solidFill>
@@ -4135,12 +4460,12 @@
             </a:r>
             <a:pPr indent="0" marL="0">
               <a:spcAft>
-                <a:spcPts val="1800"/>
+                <a:spcPts val="2600"/>
               </a:spcAft>
               <a:buNone/>
             </a:pPr>
             <a:r>
-              <a:rPr lang="en-US" sz="3000" i="1" dirty="0">
+              <a:rPr lang="en-US" sz="3400" i="1" dirty="0">
                 <a:solidFill>
                   <a:schemeClr val="tx1"/>
                 </a:solidFill>
@@ -4156,7 +4481,7 @@
       </p:sp>
       <p:sp>
         <p:nvSpPr>
-          <p:cNvPr id="7" name="Tarjeta consejo"/>
+          <p:cNvPr id="11" name="Tarjeta consejo"/>
           <p:cNvSpPr/>
           <p:nvPr/>
         </p:nvSpPr>
@@ -4183,7 +4508,7 @@
       </p:sp>
       <p:pic>
         <p:nvPicPr>
-          <p:cNvPr id="8" name="Ícono pregunta" descr="Pregunta">    </p:cNvPr>
+          <p:cNvPr id="12" name="Ícono pregunta" descr="Pregunta">    </p:cNvPr>
           <p:cNvPicPr>
             <a:picLocks noChangeAspect="1"/>
           </p:cNvPicPr>
@@ -4207,7 +4532,7 @@
       </p:pic>
       <p:sp>
         <p:nvSpPr>
-          <p:cNvPr id="9" name="Consejo"/>
+          <p:cNvPr id="13" name="Consejo"/>
           <p:cNvSpPr txBox="1"/>
           <p:nvPr/>
         </p:nvSpPr>
@@ -4342,16 +4667,39 @@
       </p:grpSpPr>
       <p:sp>
         <p:nvSpPr>
-          <p:cNvPr id="2" name="Text 8"/>
+          <p:cNvPr id="2" name="Logo MM fondo"/>
           <p:cNvSpPr/>
-          <p:nvPr>
-            <p:ph idx="110" type="title" hasCustomPrompt="1"/>
-          </p:nvPr>
-        </p:nvSpPr>
-        <p:spPr>
-          <a:xfrm>
-            <a:off x="548640" y="914400"/>
-            <a:ext cx="11064240" cy="822960"/>
+          <p:nvPr/>
+        </p:nvSpPr>
+        <p:spPr>
+          <a:xfrm>
+            <a:off x="457200" y="118872"/>
+            <a:ext cx="548640" cy="548640"/>
+          </a:xfrm>
+          <a:prstGeom prst="ellipse">
+            <a:avLst/>
+          </a:prstGeom>
+          <a:solidFill>
+            <a:schemeClr val="accent1"/>
+          </a:solidFill>
+          <a:ln w="12700">
+            <a:solidFill>
+              <a:schemeClr val="accent1"/>
+            </a:solidFill>
+            <a:prstDash val="solid"/>
+          </a:ln>
+        </p:spPr>
+      </p:sp>
+      <p:sp>
+        <p:nvSpPr>
+          <p:cNvPr id="3" name="Logo MM"/>
+          <p:cNvSpPr txBox="1"/>
+          <p:nvPr/>
+        </p:nvSpPr>
+        <p:spPr>
+          <a:xfrm>
+            <a:off x="457200" y="118872"/>
+            <a:ext cx="548640" cy="548640"/>
           </a:xfrm>
           <a:prstGeom prst="rect">
             <a:avLst/>
@@ -4363,11 +4711,11 @@
           <a:bodyPr wrap="square" lIns="0" tIns="0" rIns="0" bIns="0" rtlCol="0" anchor="ctr"/>
           <a:lstStyle/>
           <a:p>
-            <a:pPr algn="l" indent="0" marL="0">
-              <a:buNone/>
-            </a:pPr>
-            <a:r>
-              <a:rPr lang="en-US" sz="3600" b="1" dirty="0">
+            <a:pPr algn="ctr" indent="0" marL="0">
+              <a:buNone/>
+            </a:pPr>
+            <a:r>
+              <a:rPr lang="en-US" sz="2000" b="1" dirty="0">
                 <a:solidFill>
                   <a:schemeClr val="tx1"/>
                 </a:solidFill>
@@ -4375,6 +4723,113 @@
                 <a:ea typeface="Big Shoulders Display" pitchFamily="34" charset="-122"/>
                 <a:cs typeface="Big Shoulders Display" pitchFamily="34" charset="-120"/>
               </a:rPr>
+              <a:t>MM</a:t>
+            </a:r>
+            <a:endParaRPr lang="en-US" sz="2000" dirty="0"/>
+          </a:p>
+        </p:txBody>
+      </p:sp>
+      <p:sp>
+        <p:nvSpPr>
+          <p:cNvPr id="4" name="Pastilla nivel"/>
+          <p:cNvSpPr/>
+          <p:nvPr/>
+        </p:nvSpPr>
+        <p:spPr>
+          <a:xfrm>
+            <a:off x="8915400" y="182880"/>
+            <a:ext cx="2743200" cy="411480"/>
+          </a:xfrm>
+          <a:prstGeom prst="roundRect">
+            <a:avLst>
+              <a:gd name="adj" fmla="val 48889"/>
+            </a:avLst>
+          </a:prstGeom>
+          <a:solidFill>
+            <a:schemeClr val="accent1"/>
+          </a:solidFill>
+          <a:ln w="12700">
+            <a:solidFill>
+              <a:schemeClr val="accent1"/>
+            </a:solidFill>
+            <a:prstDash val="solid"/>
+          </a:ln>
+        </p:spPr>
+      </p:sp>
+      <p:sp>
+        <p:nvSpPr>
+          <p:cNvPr id="5" name="Texto pastilla nivel"/>
+          <p:cNvSpPr txBox="1"/>
+          <p:nvPr/>
+        </p:nvSpPr>
+        <p:spPr>
+          <a:xfrm>
+            <a:off x="8915400" y="182880"/>
+            <a:ext cx="2743200" cy="411480"/>
+          </a:xfrm>
+          <a:prstGeom prst="rect">
+            <a:avLst/>
+          </a:prstGeom>
+          <a:noFill/>
+          <a:ln/>
+        </p:spPr>
+        <p:txBody>
+          <a:bodyPr wrap="square" lIns="0" tIns="0" rIns="0" bIns="0" rtlCol="0" anchor="ctr"/>
+          <a:lstStyle/>
+          <a:p>
+            <a:pPr algn="ctr" indent="0" marL="0">
+              <a:buNone/>
+            </a:pPr>
+            <a:r>
+              <a:rPr lang="en-US" sz="1400" b="1" dirty="0">
+                <a:solidFill>
+                  <a:schemeClr val="tx1"/>
+                </a:solidFill>
+                <a:latin typeface="Work Sans" pitchFamily="34" charset="0"/>
+                <a:ea typeface="Work Sans" pitchFamily="34" charset="-122"/>
+                <a:cs typeface="Work Sans" pitchFamily="34" charset="-120"/>
+              </a:rPr>
+              <a:t>Beginner English Tips</a:t>
+            </a:r>
+            <a:endParaRPr lang="en-US" sz="1400" dirty="0"/>
+          </a:p>
+        </p:txBody>
+      </p:sp>
+      <p:sp>
+        <p:nvSpPr>
+          <p:cNvPr id="6" name="Text 6"/>
+          <p:cNvSpPr/>
+          <p:nvPr>
+            <p:ph idx="106" type="title" hasCustomPrompt="1"/>
+          </p:nvPr>
+        </p:nvSpPr>
+        <p:spPr>
+          <a:xfrm>
+            <a:off x="548640" y="914400"/>
+            <a:ext cx="11064240" cy="822960"/>
+          </a:xfrm>
+          <a:prstGeom prst="rect">
+            <a:avLst/>
+          </a:prstGeom>
+          <a:noFill/>
+          <a:ln/>
+        </p:spPr>
+        <p:txBody>
+          <a:bodyPr wrap="square" lIns="0" tIns="0" rIns="0" bIns="0" rtlCol="0" anchor="ctr"/>
+          <a:lstStyle/>
+          <a:p>
+            <a:pPr algn="l" indent="0" marL="0">
+              <a:buNone/>
+            </a:pPr>
+            <a:r>
+              <a:rPr lang="en-US" sz="3600" b="1" dirty="0">
+                <a:solidFill>
+                  <a:schemeClr val="tx1"/>
+                </a:solidFill>
+                <a:latin typeface="Big Shoulders Display" pitchFamily="34" charset="0"/>
+                <a:ea typeface="Big Shoulders Display" pitchFamily="34" charset="-122"/>
+                <a:cs typeface="Big Shoulders Display" pitchFamily="34" charset="-120"/>
+              </a:rPr>
               <a:t>EXPRESIÓN 1: PEDIR QUE REPITAN</a:t>
             </a:r>
             <a:endParaRPr lang="en-US" sz="3600" dirty="0"/>
@@ -4383,7 +4838,7 @@
       </p:sp>
       <p:sp>
         <p:nvSpPr>
-          <p:cNvPr id="3" name="Chip 1 fondo"/>
+          <p:cNvPr id="7" name="Chip 1 fondo"/>
           <p:cNvSpPr/>
           <p:nvPr/>
         </p:nvSpPr>
@@ -4410,7 +4865,7 @@
       </p:sp>
       <p:sp>
         <p:nvSpPr>
-          <p:cNvPr id="4" name="Chip 1 frase"/>
+          <p:cNvPr id="8" name="Chip 1 frase"/>
           <p:cNvSpPr/>
           <p:nvPr/>
         </p:nvSpPr>
@@ -4437,7 +4892,7 @@
       </p:sp>
       <p:sp>
         <p:nvSpPr>
-          <p:cNvPr id="5" name="Chip 1 texto frase"/>
+          <p:cNvPr id="9" name="Chip 1 texto frase"/>
           <p:cNvSpPr txBox="1"/>
           <p:nvPr/>
         </p:nvSpPr>
@@ -4476,7 +4931,7 @@
       </p:sp>
       <p:sp>
         <p:nvSpPr>
-          <p:cNvPr id="6" name="Chip 1 descripción"/>
+          <p:cNvPr id="10" name="Chip 1 descripción"/>
           <p:cNvSpPr txBox="1"/>
           <p:nvPr/>
         </p:nvSpPr>
@@ -4515,7 +4970,7 @@
       </p:sp>
       <p:sp>
         <p:nvSpPr>
-          <p:cNvPr id="7" name="Chip 2 fondo"/>
+          <p:cNvPr id="11" name="Chip 2 fondo"/>
           <p:cNvSpPr/>
           <p:nvPr/>
         </p:nvSpPr>
@@ -4542,7 +4997,7 @@
       </p:sp>
       <p:sp>
         <p:nvSpPr>
-          <p:cNvPr id="8" name="Chip 2 frase"/>
+          <p:cNvPr id="12" name="Chip 2 frase"/>
           <p:cNvSpPr/>
           <p:nvPr/>
         </p:nvSpPr>
@@ -4569,7 +5024,7 @@
       </p:sp>
       <p:sp>
         <p:nvSpPr>
-          <p:cNvPr id="9" name="Chip 2 texto frase"/>
+          <p:cNvPr id="13" name="Chip 2 texto frase"/>
           <p:cNvSpPr txBox="1"/>
           <p:nvPr/>
         </p:nvSpPr>
@@ -4608,7 +5063,7 @@
       </p:sp>
       <p:sp>
         <p:nvSpPr>
-          <p:cNvPr id="10" name="Chip 2 descripción"/>
+          <p:cNvPr id="14" name="Chip 2 descripción"/>
           <p:cNvSpPr txBox="1"/>
           <p:nvPr/>
         </p:nvSpPr>
@@ -4647,7 +5102,7 @@
       </p:sp>
       <p:sp>
         <p:nvSpPr>
-          <p:cNvPr id="11" name="Chip 3 fondo"/>
+          <p:cNvPr id="15" name="Chip 3 fondo"/>
           <p:cNvSpPr/>
           <p:nvPr/>
         </p:nvSpPr>
@@ -4674,7 +5129,7 @@
       </p:sp>
       <p:sp>
         <p:nvSpPr>
-          <p:cNvPr id="12" name="Chip 3 frase"/>
+          <p:cNvPr id="16" name="Chip 3 frase"/>
           <p:cNvSpPr/>
           <p:nvPr/>
         </p:nvSpPr>
@@ -4701,7 +5156,7 @@
       </p:sp>
       <p:sp>
         <p:nvSpPr>
-          <p:cNvPr id="13" name="Chip 3 texto frase"/>
+          <p:cNvPr id="17" name="Chip 3 texto frase"/>
           <p:cNvSpPr txBox="1"/>
           <p:nvPr/>
         </p:nvSpPr>
@@ -4740,7 +5195,7 @@
       </p:sp>
       <p:sp>
         <p:nvSpPr>
-          <p:cNvPr id="14" name="Chip 3 descripción"/>
+          <p:cNvPr id="18" name="Chip 3 descripción"/>
           <p:cNvSpPr txBox="1"/>
           <p:nvPr/>
         </p:nvSpPr>
@@ -4779,7 +5234,7 @@
       </p:sp>
       <p:sp>
         <p:nvSpPr>
-          <p:cNvPr id="15" name="Barra significado"/>
+          <p:cNvPr id="19" name="Barra significado"/>
           <p:cNvSpPr/>
           <p:nvPr/>
         </p:nvSpPr>
@@ -4806,7 +5261,7 @@
       </p:sp>
       <p:sp>
         <p:nvSpPr>
-          <p:cNvPr id="16" name="Significado"/>
+          <p:cNvPr id="20" name="Significado"/>
           <p:cNvSpPr txBox="1"/>
           <p:nvPr/>
         </p:nvSpPr>
@@ -4932,16 +5387,39 @@
       </p:grpSpPr>
       <p:sp>
         <p:nvSpPr>
-          <p:cNvPr id="2" name="Text 8"/>
+          <p:cNvPr id="2" name="Logo MM fondo"/>
           <p:cNvSpPr/>
-          <p:nvPr>
-            <p:ph idx="110" type="title" hasCustomPrompt="1"/>
-          </p:nvPr>
-        </p:nvSpPr>
-        <p:spPr>
-          <a:xfrm>
-            <a:off x="548640" y="914400"/>
-            <a:ext cx="11064240" cy="822960"/>
+          <p:nvPr/>
+        </p:nvSpPr>
+        <p:spPr>
+          <a:xfrm>
+            <a:off x="457200" y="118872"/>
+            <a:ext cx="548640" cy="548640"/>
+          </a:xfrm>
+          <a:prstGeom prst="ellipse">
+            <a:avLst/>
+          </a:prstGeom>
+          <a:solidFill>
+            <a:schemeClr val="accent1"/>
+          </a:solidFill>
+          <a:ln w="12700">
+            <a:solidFill>
+              <a:schemeClr val="accent1"/>
+            </a:solidFill>
+            <a:prstDash val="solid"/>
+          </a:ln>
+        </p:spPr>
+      </p:sp>
+      <p:sp>
+        <p:nvSpPr>
+          <p:cNvPr id="3" name="Logo MM"/>
+          <p:cNvSpPr txBox="1"/>
+          <p:nvPr/>
+        </p:nvSpPr>
+        <p:spPr>
+          <a:xfrm>
+            <a:off x="457200" y="118872"/>
+            <a:ext cx="548640" cy="548640"/>
           </a:xfrm>
           <a:prstGeom prst="rect">
             <a:avLst/>
@@ -4953,11 +5431,11 @@
           <a:bodyPr wrap="square" lIns="0" tIns="0" rIns="0" bIns="0" rtlCol="0" anchor="ctr"/>
           <a:lstStyle/>
           <a:p>
-            <a:pPr algn="l" indent="0" marL="0">
-              <a:buNone/>
-            </a:pPr>
-            <a:r>
-              <a:rPr lang="en-US" sz="3600" b="1" dirty="0">
+            <a:pPr algn="ctr" indent="0" marL="0">
+              <a:buNone/>
+            </a:pPr>
+            <a:r>
+              <a:rPr lang="en-US" sz="2000" b="1" dirty="0">
                 <a:solidFill>
                   <a:schemeClr val="tx1"/>
                 </a:solidFill>
@@ -4965,6 +5443,113 @@
                 <a:ea typeface="Big Shoulders Display" pitchFamily="34" charset="-122"/>
                 <a:cs typeface="Big Shoulders Display" pitchFamily="34" charset="-120"/>
               </a:rPr>
+              <a:t>MM</a:t>
+            </a:r>
+            <a:endParaRPr lang="en-US" sz="2000" dirty="0"/>
+          </a:p>
+        </p:txBody>
+      </p:sp>
+      <p:sp>
+        <p:nvSpPr>
+          <p:cNvPr id="4" name="Pastilla nivel"/>
+          <p:cNvSpPr/>
+          <p:nvPr/>
+        </p:nvSpPr>
+        <p:spPr>
+          <a:xfrm>
+            <a:off x="8915400" y="182880"/>
+            <a:ext cx="2743200" cy="411480"/>
+          </a:xfrm>
+          <a:prstGeom prst="roundRect">
+            <a:avLst>
+              <a:gd name="adj" fmla="val 48889"/>
+            </a:avLst>
+          </a:prstGeom>
+          <a:solidFill>
+            <a:schemeClr val="accent1"/>
+          </a:solidFill>
+          <a:ln w="12700">
+            <a:solidFill>
+              <a:schemeClr val="accent1"/>
+            </a:solidFill>
+            <a:prstDash val="solid"/>
+          </a:ln>
+        </p:spPr>
+      </p:sp>
+      <p:sp>
+        <p:nvSpPr>
+          <p:cNvPr id="5" name="Texto pastilla nivel"/>
+          <p:cNvSpPr txBox="1"/>
+          <p:nvPr/>
+        </p:nvSpPr>
+        <p:spPr>
+          <a:xfrm>
+            <a:off x="8915400" y="182880"/>
+            <a:ext cx="2743200" cy="411480"/>
+          </a:xfrm>
+          <a:prstGeom prst="rect">
+            <a:avLst/>
+          </a:prstGeom>
+          <a:noFill/>
+          <a:ln/>
+        </p:spPr>
+        <p:txBody>
+          <a:bodyPr wrap="square" lIns="0" tIns="0" rIns="0" bIns="0" rtlCol="0" anchor="ctr"/>
+          <a:lstStyle/>
+          <a:p>
+            <a:pPr algn="ctr" indent="0" marL="0">
+              <a:buNone/>
+            </a:pPr>
+            <a:r>
+              <a:rPr lang="en-US" sz="1400" b="1" dirty="0">
+                <a:solidFill>
+                  <a:schemeClr val="tx1"/>
+                </a:solidFill>
+                <a:latin typeface="Work Sans" pitchFamily="34" charset="0"/>
+                <a:ea typeface="Work Sans" pitchFamily="34" charset="-122"/>
+                <a:cs typeface="Work Sans" pitchFamily="34" charset="-120"/>
+              </a:rPr>
+              <a:t>Beginner English Tips</a:t>
+            </a:r>
+            <a:endParaRPr lang="en-US" sz="1400" dirty="0"/>
+          </a:p>
+        </p:txBody>
+      </p:sp>
+      <p:sp>
+        <p:nvSpPr>
+          <p:cNvPr id="6" name="Text 6"/>
+          <p:cNvSpPr/>
+          <p:nvPr>
+            <p:ph idx="106" type="title" hasCustomPrompt="1"/>
+          </p:nvPr>
+        </p:nvSpPr>
+        <p:spPr>
+          <a:xfrm>
+            <a:off x="548640" y="914400"/>
+            <a:ext cx="11064240" cy="822960"/>
+          </a:xfrm>
+          <a:prstGeom prst="rect">
+            <a:avLst/>
+          </a:prstGeom>
+          <a:noFill/>
+          <a:ln/>
+        </p:spPr>
+        <p:txBody>
+          <a:bodyPr wrap="square" lIns="0" tIns="0" rIns="0" bIns="0" rtlCol="0" anchor="ctr"/>
+          <a:lstStyle/>
+          <a:p>
+            <a:pPr algn="l" indent="0" marL="0">
+              <a:buNone/>
+            </a:pPr>
+            <a:r>
+              <a:rPr lang="en-US" sz="3600" b="1" dirty="0">
+                <a:solidFill>
+                  <a:schemeClr val="tx1"/>
+                </a:solidFill>
+                <a:latin typeface="Big Shoulders Display" pitchFamily="34" charset="0"/>
+                <a:ea typeface="Big Shoulders Display" pitchFamily="34" charset="-122"/>
+                <a:cs typeface="Big Shoulders Display" pitchFamily="34" charset="-120"/>
+              </a:rPr>
               <a:t>MODELADO EN ACCIÓN</a:t>
             </a:r>
             <a:endParaRPr lang="en-US" sz="3600" dirty="0"/>
@@ -4973,7 +5558,7 @@
       </p:sp>
       <p:sp>
         <p:nvSpPr>
-          <p:cNvPr id="3" name="Tarjeta diálogo"/>
+          <p:cNvPr id="7" name="Tarjeta diálogo"/>
           <p:cNvSpPr/>
           <p:nvPr/>
         </p:nvSpPr>
@@ -5000,7 +5585,7 @@
       </p:sp>
       <p:sp>
         <p:nvSpPr>
-          <p:cNvPr id="4" name="Diálogo"/>
+          <p:cNvPr id="8" name="Diálogo"/>
           <p:cNvSpPr txBox="1"/>
           <p:nvPr/>
         </p:nvSpPr>
@@ -5207,7 +5792,7 @@
       </p:sp>
       <p:sp>
         <p:nvSpPr>
-          <p:cNvPr id="5" name="Tarjeta explicación"/>
+          <p:cNvPr id="9" name="Tarjeta explicación"/>
           <p:cNvSpPr/>
           <p:nvPr/>
         </p:nvSpPr>
@@ -5234,7 +5819,7 @@
       </p:sp>
       <p:pic>
         <p:nvPicPr>
-          <p:cNvPr id="6" name="Ícono conversación" descr="Conversación">    </p:cNvPr>
+          <p:cNvPr id="10" name="Ícono conversación" descr="Conversación">    </p:cNvPr>
           <p:cNvPicPr>
             <a:picLocks noChangeAspect="1"/>
           </p:cNvPicPr>
@@ -5258,7 +5843,7 @@
       </p:pic>
       <p:sp>
         <p:nvSpPr>
-          <p:cNvPr id="7" name="Explicación"/>
+          <p:cNvPr id="11" name="Explicación"/>
           <p:cNvSpPr txBox="1"/>
           <p:nvPr/>
         </p:nvSpPr>
@@ -5393,16 +5978,39 @@
       </p:grpSpPr>
       <p:sp>
         <p:nvSpPr>
-          <p:cNvPr id="2" name="Text 8"/>
+          <p:cNvPr id="2" name="Logo MM fondo"/>
           <p:cNvSpPr/>
-          <p:nvPr>
-            <p:ph idx="110" type="title" hasCustomPrompt="1"/>
-          </p:nvPr>
-        </p:nvSpPr>
-        <p:spPr>
-          <a:xfrm>
-            <a:off x="548640" y="914400"/>
-            <a:ext cx="11064240" cy="822960"/>
+          <p:nvPr/>
+        </p:nvSpPr>
+        <p:spPr>
+          <a:xfrm>
+            <a:off x="457200" y="118872"/>
+            <a:ext cx="548640" cy="548640"/>
+          </a:xfrm>
+          <a:prstGeom prst="ellipse">
+            <a:avLst/>
+          </a:prstGeom>
+          <a:solidFill>
+            <a:schemeClr val="accent1"/>
+          </a:solidFill>
+          <a:ln w="12700">
+            <a:solidFill>
+              <a:schemeClr val="accent1"/>
+            </a:solidFill>
+            <a:prstDash val="solid"/>
+          </a:ln>
+        </p:spPr>
+      </p:sp>
+      <p:sp>
+        <p:nvSpPr>
+          <p:cNvPr id="3" name="Logo MM"/>
+          <p:cNvSpPr txBox="1"/>
+          <p:nvPr/>
+        </p:nvSpPr>
+        <p:spPr>
+          <a:xfrm>
+            <a:off x="457200" y="118872"/>
+            <a:ext cx="548640" cy="548640"/>
           </a:xfrm>
           <a:prstGeom prst="rect">
             <a:avLst/>
@@ -5414,11 +6022,11 @@
           <a:bodyPr wrap="square" lIns="0" tIns="0" rIns="0" bIns="0" rtlCol="0" anchor="ctr"/>
           <a:lstStyle/>
           <a:p>
-            <a:pPr algn="l" indent="0" marL="0">
-              <a:buNone/>
-            </a:pPr>
-            <a:r>
-              <a:rPr lang="en-US" sz="3600" b="1" dirty="0">
+            <a:pPr algn="ctr" indent="0" marL="0">
+              <a:buNone/>
+            </a:pPr>
+            <a:r>
+              <a:rPr lang="en-US" sz="2000" b="1" dirty="0">
                 <a:solidFill>
                   <a:schemeClr val="tx1"/>
                 </a:solidFill>
@@ -5426,6 +6034,113 @@
                 <a:ea typeface="Big Shoulders Display" pitchFamily="34" charset="-122"/>
                 <a:cs typeface="Big Shoulders Display" pitchFamily="34" charset="-120"/>
               </a:rPr>
+              <a:t>MM</a:t>
+            </a:r>
+            <a:endParaRPr lang="en-US" sz="2000" dirty="0"/>
+          </a:p>
+        </p:txBody>
+      </p:sp>
+      <p:sp>
+        <p:nvSpPr>
+          <p:cNvPr id="4" name="Pastilla nivel"/>
+          <p:cNvSpPr/>
+          <p:nvPr/>
+        </p:nvSpPr>
+        <p:spPr>
+          <a:xfrm>
+            <a:off x="8915400" y="182880"/>
+            <a:ext cx="2743200" cy="411480"/>
+          </a:xfrm>
+          <a:prstGeom prst="roundRect">
+            <a:avLst>
+              <a:gd name="adj" fmla="val 48889"/>
+            </a:avLst>
+          </a:prstGeom>
+          <a:solidFill>
+            <a:schemeClr val="accent1"/>
+          </a:solidFill>
+          <a:ln w="12700">
+            <a:solidFill>
+              <a:schemeClr val="accent1"/>
+            </a:solidFill>
+            <a:prstDash val="solid"/>
+          </a:ln>
+        </p:spPr>
+      </p:sp>
+      <p:sp>
+        <p:nvSpPr>
+          <p:cNvPr id="5" name="Texto pastilla nivel"/>
+          <p:cNvSpPr txBox="1"/>
+          <p:nvPr/>
+        </p:nvSpPr>
+        <p:spPr>
+          <a:xfrm>
+            <a:off x="8915400" y="182880"/>
+            <a:ext cx="2743200" cy="411480"/>
+          </a:xfrm>
+          <a:prstGeom prst="rect">
+            <a:avLst/>
+          </a:prstGeom>
+          <a:noFill/>
+          <a:ln/>
+        </p:spPr>
+        <p:txBody>
+          <a:bodyPr wrap="square" lIns="0" tIns="0" rIns="0" bIns="0" rtlCol="0" anchor="ctr"/>
+          <a:lstStyle/>
+          <a:p>
+            <a:pPr algn="ctr" indent="0" marL="0">
+              <a:buNone/>
+            </a:pPr>
+            <a:r>
+              <a:rPr lang="en-US" sz="1400" b="1" dirty="0">
+                <a:solidFill>
+                  <a:schemeClr val="tx1"/>
+                </a:solidFill>
+                <a:latin typeface="Work Sans" pitchFamily="34" charset="0"/>
+                <a:ea typeface="Work Sans" pitchFamily="34" charset="-122"/>
+                <a:cs typeface="Work Sans" pitchFamily="34" charset="-120"/>
+              </a:rPr>
+              <a:t>Beginner English Tips</a:t>
+            </a:r>
+            <a:endParaRPr lang="en-US" sz="1400" dirty="0"/>
+          </a:p>
+        </p:txBody>
+      </p:sp>
+      <p:sp>
+        <p:nvSpPr>
+          <p:cNvPr id="6" name="Text 6"/>
+          <p:cNvSpPr/>
+          <p:nvPr>
+            <p:ph idx="106" type="title" hasCustomPrompt="1"/>
+          </p:nvPr>
+        </p:nvSpPr>
+        <p:spPr>
+          <a:xfrm>
+            <a:off x="548640" y="914400"/>
+            <a:ext cx="11064240" cy="822960"/>
+          </a:xfrm>
+          <a:prstGeom prst="rect">
+            <a:avLst/>
+          </a:prstGeom>
+          <a:noFill/>
+          <a:ln/>
+        </p:spPr>
+        <p:txBody>
+          <a:bodyPr wrap="square" lIns="0" tIns="0" rIns="0" bIns="0" rtlCol="0" anchor="ctr"/>
+          <a:lstStyle/>
+          <a:p>
+            <a:pPr algn="l" indent="0" marL="0">
+              <a:buNone/>
+            </a:pPr>
+            <a:r>
+              <a:rPr lang="en-US" sz="3600" b="1" dirty="0">
+                <a:solidFill>
+                  <a:schemeClr val="tx1"/>
+                </a:solidFill>
+                <a:latin typeface="Big Shoulders Display" pitchFamily="34" charset="0"/>
+                <a:ea typeface="Big Shoulders Display" pitchFamily="34" charset="-122"/>
+                <a:cs typeface="Big Shoulders Display" pitchFamily="34" charset="-120"/>
+              </a:rPr>
               <a:t>EXPRESIÓN 2: LO QUE TE PASÓ</a:t>
             </a:r>
             <a:endParaRPr lang="en-US" sz="3600" dirty="0"/>
@@ -5434,7 +6149,7 @@
       </p:sp>
       <p:sp>
         <p:nvSpPr>
-          <p:cNvPr id="3" name="Chip 1 fondo"/>
+          <p:cNvPr id="7" name="Chip 1 fondo"/>
           <p:cNvSpPr/>
           <p:nvPr/>
         </p:nvSpPr>
@@ -5461,7 +6176,7 @@
       </p:sp>
       <p:sp>
         <p:nvSpPr>
-          <p:cNvPr id="4" name="Chip 1 frase"/>
+          <p:cNvPr id="8" name="Chip 1 frase"/>
           <p:cNvSpPr/>
           <p:nvPr/>
         </p:nvSpPr>
@@ -5488,7 +6203,7 @@
       </p:sp>
       <p:sp>
         <p:nvSpPr>
-          <p:cNvPr id="5" name="Chip 1 texto frase"/>
+          <p:cNvPr id="9" name="Chip 1 texto frase"/>
           <p:cNvSpPr txBox="1"/>
           <p:nvPr/>
         </p:nvSpPr>
@@ -5527,7 +6242,7 @@
       </p:sp>
       <p:sp>
         <p:nvSpPr>
-          <p:cNvPr id="6" name="Chip 1 descripción"/>
+          <p:cNvPr id="10" name="Chip 1 descripción"/>
           <p:cNvSpPr txBox="1"/>
           <p:nvPr/>
         </p:nvSpPr>
@@ -5566,7 +6281,7 @@
       </p:sp>
       <p:sp>
         <p:nvSpPr>
-          <p:cNvPr id="7" name="Chip 2 fondo"/>
+          <p:cNvPr id="11" name="Chip 2 fondo"/>
           <p:cNvSpPr/>
           <p:nvPr/>
         </p:nvSpPr>
@@ -5593,7 +6308,7 @@
       </p:sp>
       <p:sp>
         <p:nvSpPr>
-          <p:cNvPr id="8" name="Chip 2 frase"/>
+          <p:cNvPr id="12" name="Chip 2 frase"/>
           <p:cNvSpPr/>
           <p:nvPr/>
         </p:nvSpPr>
@@ -5620,7 +6335,7 @@
       </p:sp>
       <p:sp>
         <p:nvSpPr>
-          <p:cNvPr id="9" name="Chip 2 texto frase"/>
+          <p:cNvPr id="13" name="Chip 2 texto frase"/>
           <p:cNvSpPr txBox="1"/>
           <p:nvPr/>
         </p:nvSpPr>
@@ -5659,7 +6374,7 @@
       </p:sp>
       <p:sp>
         <p:nvSpPr>
-          <p:cNvPr id="10" name="Chip 2 descripción"/>
+          <p:cNvPr id="14" name="Chip 2 descripción"/>
           <p:cNvSpPr txBox="1"/>
           <p:nvPr/>
         </p:nvSpPr>
@@ -5698,7 +6413,7 @@
       </p:sp>
       <p:sp>
         <p:nvSpPr>
-          <p:cNvPr id="11" name="Chip 3 fondo"/>
+          <p:cNvPr id="15" name="Chip 3 fondo"/>
           <p:cNvSpPr/>
           <p:nvPr/>
         </p:nvSpPr>
@@ -5725,7 +6440,7 @@
       </p:sp>
       <p:sp>
         <p:nvSpPr>
-          <p:cNvPr id="12" name="Chip 3 frase"/>
+          <p:cNvPr id="16" name="Chip 3 frase"/>
           <p:cNvSpPr/>
           <p:nvPr/>
         </p:nvSpPr>
@@ -5752,7 +6467,7 @@
       </p:sp>
       <p:sp>
         <p:nvSpPr>
-          <p:cNvPr id="13" name="Chip 3 texto frase"/>
+          <p:cNvPr id="17" name="Chip 3 texto frase"/>
           <p:cNvSpPr txBox="1"/>
           <p:nvPr/>
         </p:nvSpPr>
@@ -5791,7 +6506,7 @@
       </p:sp>
       <p:sp>
         <p:nvSpPr>
-          <p:cNvPr id="14" name="Chip 3 descripción"/>
+          <p:cNvPr id="18" name="Chip 3 descripción"/>
           <p:cNvSpPr txBox="1"/>
           <p:nvPr/>
         </p:nvSpPr>
@@ -5830,7 +6545,7 @@
       </p:sp>
       <p:sp>
         <p:nvSpPr>
-          <p:cNvPr id="15" name="Barra significado y tip"/>
+          <p:cNvPr id="19" name="Barra significado y tip"/>
           <p:cNvSpPr/>
           <p:nvPr/>
         </p:nvSpPr>
@@ -5857,7 +6572,7 @@
       </p:sp>
       <p:sp>
         <p:nvSpPr>
-          <p:cNvPr id="16" name="Significado"/>
+          <p:cNvPr id="20" name="Significado"/>
           <p:cNvSpPr txBox="1"/>
           <p:nvPr/>
         </p:nvSpPr>
@@ -5910,7 +6625,7 @@
       </p:sp>
       <p:sp>
         <p:nvSpPr>
-          <p:cNvPr id="17" name="Tip Mercedes"/>
+          <p:cNvPr id="21" name="Tip Mercedes"/>
           <p:cNvSpPr txBox="1"/>
           <p:nvPr/>
         </p:nvSpPr>
@@ -6036,16 +6751,39 @@
       </p:grpSpPr>
       <p:sp>
         <p:nvSpPr>
-          <p:cNvPr id="2" name="Text 8"/>
+          <p:cNvPr id="2" name="Logo MM fondo"/>
           <p:cNvSpPr/>
-          <p:nvPr>
-            <p:ph idx="110" type="title" hasCustomPrompt="1"/>
-          </p:nvPr>
-        </p:nvSpPr>
-        <p:spPr>
-          <a:xfrm>
-            <a:off x="548640" y="914400"/>
-            <a:ext cx="11064240" cy="822960"/>
+          <p:nvPr/>
+        </p:nvSpPr>
+        <p:spPr>
+          <a:xfrm>
+            <a:off x="457200" y="118872"/>
+            <a:ext cx="548640" cy="548640"/>
+          </a:xfrm>
+          <a:prstGeom prst="ellipse">
+            <a:avLst/>
+          </a:prstGeom>
+          <a:solidFill>
+            <a:schemeClr val="accent1"/>
+          </a:solidFill>
+          <a:ln w="12700">
+            <a:solidFill>
+              <a:schemeClr val="accent1"/>
+            </a:solidFill>
+            <a:prstDash val="solid"/>
+          </a:ln>
+        </p:spPr>
+      </p:sp>
+      <p:sp>
+        <p:nvSpPr>
+          <p:cNvPr id="3" name="Logo MM"/>
+          <p:cNvSpPr txBox="1"/>
+          <p:nvPr/>
+        </p:nvSpPr>
+        <p:spPr>
+          <a:xfrm>
+            <a:off x="457200" y="118872"/>
+            <a:ext cx="548640" cy="548640"/>
           </a:xfrm>
           <a:prstGeom prst="rect">
             <a:avLst/>
@@ -6057,11 +6795,11 @@
           <a:bodyPr wrap="square" lIns="0" tIns="0" rIns="0" bIns="0" rtlCol="0" anchor="ctr"/>
           <a:lstStyle/>
           <a:p>
-            <a:pPr algn="l" indent="0" marL="0">
-              <a:buNone/>
-            </a:pPr>
-            <a:r>
-              <a:rPr lang="en-US" sz="3600" b="1" dirty="0">
+            <a:pPr algn="ctr" indent="0" marL="0">
+              <a:buNone/>
+            </a:pPr>
+            <a:r>
+              <a:rPr lang="en-US" sz="2000" b="1" dirty="0">
                 <a:solidFill>
                   <a:schemeClr val="tx1"/>
                 </a:solidFill>
@@ -6069,6 +6807,113 @@
                 <a:ea typeface="Big Shoulders Display" pitchFamily="34" charset="-122"/>
                 <a:cs typeface="Big Shoulders Display" pitchFamily="34" charset="-120"/>
               </a:rPr>
+              <a:t>MM</a:t>
+            </a:r>
+            <a:endParaRPr lang="en-US" sz="2000" dirty="0"/>
+          </a:p>
+        </p:txBody>
+      </p:sp>
+      <p:sp>
+        <p:nvSpPr>
+          <p:cNvPr id="4" name="Pastilla nivel"/>
+          <p:cNvSpPr/>
+          <p:nvPr/>
+        </p:nvSpPr>
+        <p:spPr>
+          <a:xfrm>
+            <a:off x="8915400" y="182880"/>
+            <a:ext cx="2743200" cy="411480"/>
+          </a:xfrm>
+          <a:prstGeom prst="roundRect">
+            <a:avLst>
+              <a:gd name="adj" fmla="val 48889"/>
+            </a:avLst>
+          </a:prstGeom>
+          <a:solidFill>
+            <a:schemeClr val="accent1"/>
+          </a:solidFill>
+          <a:ln w="12700">
+            <a:solidFill>
+              <a:schemeClr val="accent1"/>
+            </a:solidFill>
+            <a:prstDash val="solid"/>
+          </a:ln>
+        </p:spPr>
+      </p:sp>
+      <p:sp>
+        <p:nvSpPr>
+          <p:cNvPr id="5" name="Texto pastilla nivel"/>
+          <p:cNvSpPr txBox="1"/>
+          <p:nvPr/>
+        </p:nvSpPr>
+        <p:spPr>
+          <a:xfrm>
+            <a:off x="8915400" y="182880"/>
+            <a:ext cx="2743200" cy="411480"/>
+          </a:xfrm>
+          <a:prstGeom prst="rect">
+            <a:avLst/>
+          </a:prstGeom>
+          <a:noFill/>
+          <a:ln/>
+        </p:spPr>
+        <p:txBody>
+          <a:bodyPr wrap="square" lIns="0" tIns="0" rIns="0" bIns="0" rtlCol="0" anchor="ctr"/>
+          <a:lstStyle/>
+          <a:p>
+            <a:pPr algn="ctr" indent="0" marL="0">
+              <a:buNone/>
+            </a:pPr>
+            <a:r>
+              <a:rPr lang="en-US" sz="1400" b="1" dirty="0">
+                <a:solidFill>
+                  <a:schemeClr val="tx1"/>
+                </a:solidFill>
+                <a:latin typeface="Work Sans" pitchFamily="34" charset="0"/>
+                <a:ea typeface="Work Sans" pitchFamily="34" charset="-122"/>
+                <a:cs typeface="Work Sans" pitchFamily="34" charset="-120"/>
+              </a:rPr>
+              <a:t>Beginner English Tips</a:t>
+            </a:r>
+            <a:endParaRPr lang="en-US" sz="1400" dirty="0"/>
+          </a:p>
+        </p:txBody>
+      </p:sp>
+      <p:sp>
+        <p:nvSpPr>
+          <p:cNvPr id="6" name="Text 6"/>
+          <p:cNvSpPr/>
+          <p:nvPr>
+            <p:ph idx="106" type="title" hasCustomPrompt="1"/>
+          </p:nvPr>
+        </p:nvSpPr>
+        <p:spPr>
+          <a:xfrm>
+            <a:off x="548640" y="914400"/>
+            <a:ext cx="11064240" cy="822960"/>
+          </a:xfrm>
+          <a:prstGeom prst="rect">
+            <a:avLst/>
+          </a:prstGeom>
+          <a:noFill/>
+          <a:ln/>
+        </p:spPr>
+        <p:txBody>
+          <a:bodyPr wrap="square" lIns="0" tIns="0" rIns="0" bIns="0" rtlCol="0" anchor="ctr"/>
+          <a:lstStyle/>
+          <a:p>
+            <a:pPr algn="l" indent="0" marL="0">
+              <a:buNone/>
+            </a:pPr>
+            <a:r>
+              <a:rPr lang="en-US" sz="3600" b="1" dirty="0">
+                <a:solidFill>
+                  <a:schemeClr val="tx1"/>
+                </a:solidFill>
+                <a:latin typeface="Big Shoulders Display" pitchFamily="34" charset="0"/>
+                <a:ea typeface="Big Shoulders Display" pitchFamily="34" charset="-122"/>
+                <a:cs typeface="Big Shoulders Display" pitchFamily="34" charset="-120"/>
+              </a:rPr>
               <a:t>OTRO EJEMPLO: ¿DÓNDE VIVES?</a:t>
             </a:r>
             <a:endParaRPr lang="en-US" sz="3600" dirty="0"/>
@@ -6077,7 +6922,7 @@
       </p:sp>
       <p:sp>
         <p:nvSpPr>
-          <p:cNvPr id="3" name="Tarjeta diálogo"/>
+          <p:cNvPr id="7" name="Tarjeta diálogo"/>
           <p:cNvSpPr/>
           <p:nvPr/>
         </p:nvSpPr>
@@ -6104,7 +6949,7 @@
       </p:sp>
       <p:sp>
         <p:nvSpPr>
-          <p:cNvPr id="4" name="Diálogo"/>
+          <p:cNvPr id="8" name="Diálogo"/>
           <p:cNvSpPr txBox="1"/>
           <p:nvPr/>
         </p:nvSpPr>
@@ -6311,7 +7156,7 @@
       </p:sp>
       <p:sp>
         <p:nvSpPr>
-          <p:cNvPr id="5" name="Tarjeta explicación"/>
+          <p:cNvPr id="9" name="Tarjeta explicación"/>
           <p:cNvSpPr/>
           <p:nvPr/>
         </p:nvSpPr>
@@ -6338,7 +7183,7 @@
       </p:sp>
       <p:pic>
         <p:nvPicPr>
-          <p:cNvPr id="6" name="Ícono conversación" descr="Conversación">    </p:cNvPr>
+          <p:cNvPr id="10" name="Ícono conversación" descr="Conversación">    </p:cNvPr>
           <p:cNvPicPr>
             <a:picLocks noChangeAspect="1"/>
           </p:cNvPicPr>
@@ -6362,7 +7207,7 @@
       </p:pic>
       <p:sp>
         <p:nvSpPr>
-          <p:cNvPr id="7" name="Explicación"/>
+          <p:cNvPr id="11" name="Explicación"/>
           <p:cNvSpPr txBox="1"/>
           <p:nvPr/>
         </p:nvSpPr>
@@ -6497,16 +7342,39 @@
       </p:grpSpPr>
       <p:sp>
         <p:nvSpPr>
-          <p:cNvPr id="2" name="Text 8"/>
+          <p:cNvPr id="2" name="Logo MM fondo"/>
           <p:cNvSpPr/>
-          <p:nvPr>
-            <p:ph idx="110" type="title" hasCustomPrompt="1"/>
-          </p:nvPr>
-        </p:nvSpPr>
-        <p:spPr>
-          <a:xfrm>
-            <a:off x="548640" y="914400"/>
-            <a:ext cx="11064240" cy="822960"/>
+          <p:nvPr/>
+        </p:nvSpPr>
+        <p:spPr>
+          <a:xfrm>
+            <a:off x="457200" y="118872"/>
+            <a:ext cx="548640" cy="548640"/>
+          </a:xfrm>
+          <a:prstGeom prst="ellipse">
+            <a:avLst/>
+          </a:prstGeom>
+          <a:solidFill>
+            <a:schemeClr val="accent1"/>
+          </a:solidFill>
+          <a:ln w="12700">
+            <a:solidFill>
+              <a:schemeClr val="accent1"/>
+            </a:solidFill>
+            <a:prstDash val="solid"/>
+          </a:ln>
+        </p:spPr>
+      </p:sp>
+      <p:sp>
+        <p:nvSpPr>
+          <p:cNvPr id="3" name="Logo MM"/>
+          <p:cNvSpPr txBox="1"/>
+          <p:nvPr/>
+        </p:nvSpPr>
+        <p:spPr>
+          <a:xfrm>
+            <a:off x="457200" y="118872"/>
+            <a:ext cx="548640" cy="548640"/>
           </a:xfrm>
           <a:prstGeom prst="rect">
             <a:avLst/>
@@ -6518,11 +7386,11 @@
           <a:bodyPr wrap="square" lIns="0" tIns="0" rIns="0" bIns="0" rtlCol="0" anchor="ctr"/>
           <a:lstStyle/>
           <a:p>
-            <a:pPr algn="l" indent="0" marL="0">
-              <a:buNone/>
-            </a:pPr>
-            <a:r>
-              <a:rPr lang="en-US" sz="3600" b="1" dirty="0">
+            <a:pPr algn="ctr" indent="0" marL="0">
+              <a:buNone/>
+            </a:pPr>
+            <a:r>
+              <a:rPr lang="en-US" sz="2000" b="1" dirty="0">
                 <a:solidFill>
                   <a:schemeClr val="tx1"/>
                 </a:solidFill>
@@ -6530,6 +7398,113 @@
                 <a:ea typeface="Big Shoulders Display" pitchFamily="34" charset="-122"/>
                 <a:cs typeface="Big Shoulders Display" pitchFamily="34" charset="-120"/>
               </a:rPr>
+              <a:t>MM</a:t>
+            </a:r>
+            <a:endParaRPr lang="en-US" sz="2000" dirty="0"/>
+          </a:p>
+        </p:txBody>
+      </p:sp>
+      <p:sp>
+        <p:nvSpPr>
+          <p:cNvPr id="4" name="Pastilla nivel"/>
+          <p:cNvSpPr/>
+          <p:nvPr/>
+        </p:nvSpPr>
+        <p:spPr>
+          <a:xfrm>
+            <a:off x="8915400" y="182880"/>
+            <a:ext cx="2743200" cy="411480"/>
+          </a:xfrm>
+          <a:prstGeom prst="roundRect">
+            <a:avLst>
+              <a:gd name="adj" fmla="val 48889"/>
+            </a:avLst>
+          </a:prstGeom>
+          <a:solidFill>
+            <a:schemeClr val="accent1"/>
+          </a:solidFill>
+          <a:ln w="12700">
+            <a:solidFill>
+              <a:schemeClr val="accent1"/>
+            </a:solidFill>
+            <a:prstDash val="solid"/>
+          </a:ln>
+        </p:spPr>
+      </p:sp>
+      <p:sp>
+        <p:nvSpPr>
+          <p:cNvPr id="5" name="Texto pastilla nivel"/>
+          <p:cNvSpPr txBox="1"/>
+          <p:nvPr/>
+        </p:nvSpPr>
+        <p:spPr>
+          <a:xfrm>
+            <a:off x="8915400" y="182880"/>
+            <a:ext cx="2743200" cy="411480"/>
+          </a:xfrm>
+          <a:prstGeom prst="rect">
+            <a:avLst/>
+          </a:prstGeom>
+          <a:noFill/>
+          <a:ln/>
+        </p:spPr>
+        <p:txBody>
+          <a:bodyPr wrap="square" lIns="0" tIns="0" rIns="0" bIns="0" rtlCol="0" anchor="ctr"/>
+          <a:lstStyle/>
+          <a:p>
+            <a:pPr algn="ctr" indent="0" marL="0">
+              <a:buNone/>
+            </a:pPr>
+            <a:r>
+              <a:rPr lang="en-US" sz="1400" b="1" dirty="0">
+                <a:solidFill>
+                  <a:schemeClr val="tx1"/>
+                </a:solidFill>
+                <a:latin typeface="Work Sans" pitchFamily="34" charset="0"/>
+                <a:ea typeface="Work Sans" pitchFamily="34" charset="-122"/>
+                <a:cs typeface="Work Sans" pitchFamily="34" charset="-120"/>
+              </a:rPr>
+              <a:t>Beginner English Tips</a:t>
+            </a:r>
+            <a:endParaRPr lang="en-US" sz="1400" dirty="0"/>
+          </a:p>
+        </p:txBody>
+      </p:sp>
+      <p:sp>
+        <p:nvSpPr>
+          <p:cNvPr id="6" name="Text 6"/>
+          <p:cNvSpPr/>
+          <p:nvPr>
+            <p:ph idx="106" type="title" hasCustomPrompt="1"/>
+          </p:nvPr>
+        </p:nvSpPr>
+        <p:spPr>
+          <a:xfrm>
+            <a:off x="548640" y="914400"/>
+            <a:ext cx="11064240" cy="822960"/>
+          </a:xfrm>
+          <a:prstGeom prst="rect">
+            <a:avLst/>
+          </a:prstGeom>
+          <a:noFill/>
+          <a:ln/>
+        </p:spPr>
+        <p:txBody>
+          <a:bodyPr wrap="square" lIns="0" tIns="0" rIns="0" bIns="0" rtlCol="0" anchor="ctr"/>
+          <a:lstStyle/>
+          <a:p>
+            <a:pPr algn="l" indent="0" marL="0">
+              <a:buNone/>
+            </a:pPr>
+            <a:r>
+              <a:rPr lang="en-US" sz="3600" b="1" dirty="0">
+                <a:solidFill>
+                  <a:schemeClr val="tx1"/>
+                </a:solidFill>
+                <a:latin typeface="Big Shoulders Display" pitchFamily="34" charset="0"/>
+                <a:ea typeface="Big Shoulders Display" pitchFamily="34" charset="-122"/>
+                <a:cs typeface="Big Shoulders Display" pitchFamily="34" charset="-120"/>
+              </a:rPr>
               <a:t>PRÁCTICA GUIADA: TE TOCA</a:t>
             </a:r>
             <a:endParaRPr lang="en-US" sz="3600" dirty="0"/>
@@ -6538,7 +7513,7 @@
       </p:sp>
       <p:sp>
         <p:nvSpPr>
-          <p:cNvPr id="3" name="Tarjeta escucha"/>
+          <p:cNvPr id="7" name="Tarjeta escucha"/>
           <p:cNvSpPr/>
           <p:nvPr/>
         </p:nvSpPr>
@@ -6565,7 +7540,7 @@
       </p:sp>
       <p:pic>
         <p:nvPicPr>
-          <p:cNvPr id="4" name="Ícono audio" descr="Altavoz">    </p:cNvPr>
+          <p:cNvPr id="8" name="Ícono audio" descr="Altavoz">    </p:cNvPr>
           <p:cNvPicPr>
             <a:picLocks noChangeAspect="1"/>
           </p:cNvPicPr>
@@ -6589,7 +7564,7 @@
       </p:pic>
       <p:sp>
         <p:nvSpPr>
-          <p:cNvPr id="5" name="Escucha"/>
+          <p:cNvPr id="9" name="Escucha"/>
           <p:cNvSpPr txBox="1"/>
           <p:nvPr/>
         </p:nvSpPr>
@@ -6651,7 +7626,7 @@
       </p:sp>
       <p:sp>
         <p:nvSpPr>
-          <p:cNvPr id="6" name="Tarjeta pregunta"/>
+          <p:cNvPr id="10" name="Tarjeta pregunta"/>
           <p:cNvSpPr/>
           <p:nvPr/>
         </p:nvSpPr>
@@ -6678,7 +7653,7 @@
       </p:sp>
       <p:pic>
         <p:nvPicPr>
-          <p:cNvPr id="7" name="Ícono pregunta" descr="Pregunta">    </p:cNvPr>
+          <p:cNvPr id="11" name="Ícono pregunta" descr="Pregunta">    </p:cNvPr>
           <p:cNvPicPr>
             <a:picLocks noChangeAspect="1"/>
           </p:cNvPicPr>
@@ -6702,7 +7677,7 @@
       </p:pic>
       <p:sp>
         <p:nvSpPr>
-          <p:cNvPr id="8" name="Pregunta"/>
+          <p:cNvPr id="12" name="Pregunta"/>
           <p:cNvSpPr txBox="1"/>
           <p:nvPr/>
         </p:nvSpPr>
@@ -6741,13 +7716,13 @@
       </p:sp>
       <p:sp>
         <p:nvSpPr>
-          <p:cNvPr id="9" name="Marco avatar"/>
+          <p:cNvPr id="13" name="Marco avatar"/>
           <p:cNvSpPr/>
           <p:nvPr/>
         </p:nvSpPr>
         <p:spPr>
           <a:xfrm>
-            <a:off x="8823960" y="1874520"/>
+            <a:off x="8686800" y="1874520"/>
             <a:ext cx="2963647" cy="3657600"/>
           </a:xfrm>
           <a:prstGeom prst="roundRect">
@@ -6768,7 +7743,7 @@
       </p:sp>
       <p:pic>
         <p:nvPicPr>
-          <p:cNvPr id="10" name="Avatar Mercedes" descr="Mercedes, profesora de MMercedesEnglish">    </p:cNvPr>
+          <p:cNvPr id="14" name="Avatar Mercedes" descr="Mercedes, profesora de MMercedesEnglish">    </p:cNvPr>
           <p:cNvPicPr>
             <a:picLocks noChangeAspect="1"/>
           </p:cNvPicPr>
@@ -6782,7 +7757,7 @@
         </p:blipFill>
         <p:spPr>
           <a:xfrm>
-            <a:off x="8915400" y="1965960"/>
+            <a:off x="8778240" y="1965960"/>
             <a:ext cx="2780767" cy="3474720"/>
           </a:xfrm>
           <a:prstGeom prst="rect">
@@ -6865,16 +7840,39 @@
       </p:grpSpPr>
       <p:sp>
         <p:nvSpPr>
-          <p:cNvPr id="2" name="Text 8"/>
+          <p:cNvPr id="2" name="Logo MM fondo"/>
           <p:cNvSpPr/>
-          <p:nvPr>
-            <p:ph idx="110" type="title" hasCustomPrompt="1"/>
-          </p:nvPr>
-        </p:nvSpPr>
-        <p:spPr>
-          <a:xfrm>
-            <a:off x="548640" y="914400"/>
-            <a:ext cx="11064240" cy="822960"/>
+          <p:nvPr/>
+        </p:nvSpPr>
+        <p:spPr>
+          <a:xfrm>
+            <a:off x="457200" y="118872"/>
+            <a:ext cx="548640" cy="548640"/>
+          </a:xfrm>
+          <a:prstGeom prst="ellipse">
+            <a:avLst/>
+          </a:prstGeom>
+          <a:solidFill>
+            <a:schemeClr val="accent1"/>
+          </a:solidFill>
+          <a:ln w="12700">
+            <a:solidFill>
+              <a:schemeClr val="accent1"/>
+            </a:solidFill>
+            <a:prstDash val="solid"/>
+          </a:ln>
+        </p:spPr>
+      </p:sp>
+      <p:sp>
+        <p:nvSpPr>
+          <p:cNvPr id="3" name="Logo MM"/>
+          <p:cNvSpPr txBox="1"/>
+          <p:nvPr/>
+        </p:nvSpPr>
+        <p:spPr>
+          <a:xfrm>
+            <a:off x="457200" y="118872"/>
+            <a:ext cx="548640" cy="548640"/>
           </a:xfrm>
           <a:prstGeom prst="rect">
             <a:avLst/>
@@ -6886,11 +7884,11 @@
           <a:bodyPr wrap="square" lIns="0" tIns="0" rIns="0" bIns="0" rtlCol="0" anchor="ctr"/>
           <a:lstStyle/>
           <a:p>
-            <a:pPr algn="l" indent="0" marL="0">
-              <a:buNone/>
-            </a:pPr>
-            <a:r>
-              <a:rPr lang="en-US" sz="3600" b="1" dirty="0">
+            <a:pPr algn="ctr" indent="0" marL="0">
+              <a:buNone/>
+            </a:pPr>
+            <a:r>
+              <a:rPr lang="en-US" sz="2000" b="1" dirty="0">
                 <a:solidFill>
                   <a:schemeClr val="tx1"/>
                 </a:solidFill>
@@ -6898,6 +7896,113 @@
                 <a:ea typeface="Big Shoulders Display" pitchFamily="34" charset="-122"/>
                 <a:cs typeface="Big Shoulders Display" pitchFamily="34" charset="-120"/>
               </a:rPr>
+              <a:t>MM</a:t>
+            </a:r>
+            <a:endParaRPr lang="en-US" sz="2000" dirty="0"/>
+          </a:p>
+        </p:txBody>
+      </p:sp>
+      <p:sp>
+        <p:nvSpPr>
+          <p:cNvPr id="4" name="Pastilla nivel"/>
+          <p:cNvSpPr/>
+          <p:nvPr/>
+        </p:nvSpPr>
+        <p:spPr>
+          <a:xfrm>
+            <a:off x="8915400" y="182880"/>
+            <a:ext cx="2743200" cy="411480"/>
+          </a:xfrm>
+          <a:prstGeom prst="roundRect">
+            <a:avLst>
+              <a:gd name="adj" fmla="val 48889"/>
+            </a:avLst>
+          </a:prstGeom>
+          <a:solidFill>
+            <a:schemeClr val="accent1"/>
+          </a:solidFill>
+          <a:ln w="12700">
+            <a:solidFill>
+              <a:schemeClr val="accent1"/>
+            </a:solidFill>
+            <a:prstDash val="solid"/>
+          </a:ln>
+        </p:spPr>
+      </p:sp>
+      <p:sp>
+        <p:nvSpPr>
+          <p:cNvPr id="5" name="Texto pastilla nivel"/>
+          <p:cNvSpPr txBox="1"/>
+          <p:nvPr/>
+        </p:nvSpPr>
+        <p:spPr>
+          <a:xfrm>
+            <a:off x="8915400" y="182880"/>
+            <a:ext cx="2743200" cy="411480"/>
+          </a:xfrm>
+          <a:prstGeom prst="rect">
+            <a:avLst/>
+          </a:prstGeom>
+          <a:noFill/>
+          <a:ln/>
+        </p:spPr>
+        <p:txBody>
+          <a:bodyPr wrap="square" lIns="0" tIns="0" rIns="0" bIns="0" rtlCol="0" anchor="ctr"/>
+          <a:lstStyle/>
+          <a:p>
+            <a:pPr algn="ctr" indent="0" marL="0">
+              <a:buNone/>
+            </a:pPr>
+            <a:r>
+              <a:rPr lang="en-US" sz="1400" b="1" dirty="0">
+                <a:solidFill>
+                  <a:schemeClr val="tx1"/>
+                </a:solidFill>
+                <a:latin typeface="Work Sans" pitchFamily="34" charset="0"/>
+                <a:ea typeface="Work Sans" pitchFamily="34" charset="-122"/>
+                <a:cs typeface="Work Sans" pitchFamily="34" charset="-120"/>
+              </a:rPr>
+              <a:t>Beginner English Tips</a:t>
+            </a:r>
+            <a:endParaRPr lang="en-US" sz="1400" dirty="0"/>
+          </a:p>
+        </p:txBody>
+      </p:sp>
+      <p:sp>
+        <p:nvSpPr>
+          <p:cNvPr id="6" name="Text 6"/>
+          <p:cNvSpPr/>
+          <p:nvPr>
+            <p:ph idx="106" type="title" hasCustomPrompt="1"/>
+          </p:nvPr>
+        </p:nvSpPr>
+        <p:spPr>
+          <a:xfrm>
+            <a:off x="548640" y="914400"/>
+            <a:ext cx="11064240" cy="822960"/>
+          </a:xfrm>
+          <a:prstGeom prst="rect">
+            <a:avLst/>
+          </a:prstGeom>
+          <a:noFill/>
+          <a:ln/>
+        </p:spPr>
+        <p:txBody>
+          <a:bodyPr wrap="square" lIns="0" tIns="0" rIns="0" bIns="0" rtlCol="0" anchor="ctr"/>
+          <a:lstStyle/>
+          <a:p>
+            <a:pPr algn="l" indent="0" marL="0">
+              <a:buNone/>
+            </a:pPr>
+            <a:r>
+              <a:rPr lang="en-US" sz="3600" b="1" dirty="0">
+                <a:solidFill>
+                  <a:schemeClr val="tx1"/>
+                </a:solidFill>
+                <a:latin typeface="Big Shoulders Display" pitchFamily="34" charset="0"/>
+                <a:ea typeface="Big Shoulders Display" pitchFamily="34" charset="-122"/>
+                <a:cs typeface="Big Shoulders Display" pitchFamily="34" charset="-120"/>
+              </a:rPr>
               <a:t>PRÁCTICA GUIADA: RESPUESTAS</a:t>
             </a:r>
             <a:endParaRPr lang="en-US" sz="3600" dirty="0"/>
@@ -6906,7 +8011,7 @@
       </p:sp>
       <p:sp>
         <p:nvSpPr>
-          <p:cNvPr id="3" name="Opción 1"/>
+          <p:cNvPr id="7" name="Opción 1"/>
           <p:cNvSpPr/>
           <p:nvPr/>
         </p:nvSpPr>
@@ -6933,7 +8038,7 @@
       </p:sp>
       <p:sp>
         <p:nvSpPr>
-          <p:cNvPr id="4" name="Etiqueta opción 1"/>
+          <p:cNvPr id="8" name="Etiqueta opción 1"/>
           <p:cNvSpPr txBox="1"/>
           <p:nvPr/>
         </p:nvSpPr>
@@ -6972,7 +8077,7 @@
       </p:sp>
       <p:sp>
         <p:nvSpPr>
-          <p:cNvPr id="5" name="Frase opción 1"/>
+          <p:cNvPr id="9" name="Frase opción 1"/>
           <p:cNvSpPr txBox="1"/>
           <p:nvPr/>
         </p:nvSpPr>
@@ -7011,7 +8116,7 @@
       </p:sp>
       <p:sp>
         <p:nvSpPr>
-          <p:cNvPr id="6" name="Opción 2"/>
+          <p:cNvPr id="10" name="Opción 2"/>
           <p:cNvSpPr/>
           <p:nvPr/>
         </p:nvSpPr>
@@ -7038,7 +8143,7 @@
       </p:sp>
       <p:sp>
         <p:nvSpPr>
-          <p:cNvPr id="7" name="Etiqueta opción 2"/>
+          <p:cNvPr id="11" name="Etiqueta opción 2"/>
           <p:cNvSpPr txBox="1"/>
           <p:nvPr/>
         </p:nvSpPr>
@@ -7077,7 +8182,7 @@
       </p:sp>
       <p:sp>
         <p:nvSpPr>
-          <p:cNvPr id="8" name="Frase opción 2"/>
+          <p:cNvPr id="12" name="Frase opción 2"/>
           <p:cNvSpPr txBox="1"/>
           <p:nvPr/>
         </p:nvSpPr>
@@ -7116,7 +8221,7 @@
       </p:sp>
       <p:sp>
         <p:nvSpPr>
-          <p:cNvPr id="9" name="Respuesta"/>
+          <p:cNvPr id="13" name="Respuesta"/>
           <p:cNvSpPr/>
           <p:nvPr/>
         </p:nvSpPr>
@@ -7143,7 +8248,7 @@
       </p:sp>
       <p:pic>
         <p:nvPicPr>
-          <p:cNvPr id="10" name="Ícono check" descr="Correcto">    </p:cNvPr>
+          <p:cNvPr id="14" name="Ícono check" descr="Correcto">    </p:cNvPr>
           <p:cNvPicPr>
             <a:picLocks noChangeAspect="1"/>
           </p:cNvPicPr>
@@ -7167,7 +8272,7 @@
       </p:pic>
       <p:sp>
         <p:nvSpPr>
-          <p:cNvPr id="11" name="Frase respuesta"/>
+          <p:cNvPr id="15" name="Frase respuesta"/>
           <p:cNvSpPr txBox="1"/>
           <p:nvPr/>
         </p:nvSpPr>
@@ -7302,16 +8407,39 @@
       </p:grpSpPr>
       <p:sp>
         <p:nvSpPr>
-          <p:cNvPr id="2" name="Text 8"/>
+          <p:cNvPr id="2" name="Logo MM fondo"/>
           <p:cNvSpPr/>
-          <p:nvPr>
-            <p:ph idx="110" type="title" hasCustomPrompt="1"/>
-          </p:nvPr>
-        </p:nvSpPr>
-        <p:spPr>
-          <a:xfrm>
-            <a:off x="548640" y="914400"/>
-            <a:ext cx="11064240" cy="822960"/>
+          <p:nvPr/>
+        </p:nvSpPr>
+        <p:spPr>
+          <a:xfrm>
+            <a:off x="457200" y="118872"/>
+            <a:ext cx="548640" cy="548640"/>
+          </a:xfrm>
+          <a:prstGeom prst="ellipse">
+            <a:avLst/>
+          </a:prstGeom>
+          <a:solidFill>
+            <a:schemeClr val="accent1"/>
+          </a:solidFill>
+          <a:ln w="12700">
+            <a:solidFill>
+              <a:schemeClr val="accent1"/>
+            </a:solidFill>
+            <a:prstDash val="solid"/>
+          </a:ln>
+        </p:spPr>
+      </p:sp>
+      <p:sp>
+        <p:nvSpPr>
+          <p:cNvPr id="3" name="Logo MM"/>
+          <p:cNvSpPr txBox="1"/>
+          <p:nvPr/>
+        </p:nvSpPr>
+        <p:spPr>
+          <a:xfrm>
+            <a:off x="457200" y="118872"/>
+            <a:ext cx="548640" cy="548640"/>
           </a:xfrm>
           <a:prstGeom prst="rect">
             <a:avLst/>
@@ -7323,11 +8451,11 @@
           <a:bodyPr wrap="square" lIns="0" tIns="0" rIns="0" bIns="0" rtlCol="0" anchor="ctr"/>
           <a:lstStyle/>
           <a:p>
-            <a:pPr algn="l" indent="0" marL="0">
-              <a:buNone/>
-            </a:pPr>
-            <a:r>
-              <a:rPr lang="en-US" sz="3600" b="1" dirty="0">
+            <a:pPr algn="ctr" indent="0" marL="0">
+              <a:buNone/>
+            </a:pPr>
+            <a:r>
+              <a:rPr lang="en-US" sz="2000" b="1" dirty="0">
                 <a:solidFill>
                   <a:schemeClr val="tx1"/>
                 </a:solidFill>
@@ -7335,6 +8463,113 @@
                 <a:ea typeface="Big Shoulders Display" pitchFamily="34" charset="-122"/>
                 <a:cs typeface="Big Shoulders Display" pitchFamily="34" charset="-120"/>
               </a:rPr>
+              <a:t>MM</a:t>
+            </a:r>
+            <a:endParaRPr lang="en-US" sz="2000" dirty="0"/>
+          </a:p>
+        </p:txBody>
+      </p:sp>
+      <p:sp>
+        <p:nvSpPr>
+          <p:cNvPr id="4" name="Pastilla nivel"/>
+          <p:cNvSpPr/>
+          <p:nvPr/>
+        </p:nvSpPr>
+        <p:spPr>
+          <a:xfrm>
+            <a:off x="8915400" y="182880"/>
+            <a:ext cx="2743200" cy="411480"/>
+          </a:xfrm>
+          <a:prstGeom prst="roundRect">
+            <a:avLst>
+              <a:gd name="adj" fmla="val 48889"/>
+            </a:avLst>
+          </a:prstGeom>
+          <a:solidFill>
+            <a:schemeClr val="accent1"/>
+          </a:solidFill>
+          <a:ln w="12700">
+            <a:solidFill>
+              <a:schemeClr val="accent1"/>
+            </a:solidFill>
+            <a:prstDash val="solid"/>
+          </a:ln>
+        </p:spPr>
+      </p:sp>
+      <p:sp>
+        <p:nvSpPr>
+          <p:cNvPr id="5" name="Texto pastilla nivel"/>
+          <p:cNvSpPr txBox="1"/>
+          <p:nvPr/>
+        </p:nvSpPr>
+        <p:spPr>
+          <a:xfrm>
+            <a:off x="8915400" y="182880"/>
+            <a:ext cx="2743200" cy="411480"/>
+          </a:xfrm>
+          <a:prstGeom prst="rect">
+            <a:avLst/>
+          </a:prstGeom>
+          <a:noFill/>
+          <a:ln/>
+        </p:spPr>
+        <p:txBody>
+          <a:bodyPr wrap="square" lIns="0" tIns="0" rIns="0" bIns="0" rtlCol="0" anchor="ctr"/>
+          <a:lstStyle/>
+          <a:p>
+            <a:pPr algn="ctr" indent="0" marL="0">
+              <a:buNone/>
+            </a:pPr>
+            <a:r>
+              <a:rPr lang="en-US" sz="1400" b="1" dirty="0">
+                <a:solidFill>
+                  <a:schemeClr val="tx1"/>
+                </a:solidFill>
+                <a:latin typeface="Work Sans" pitchFamily="34" charset="0"/>
+                <a:ea typeface="Work Sans" pitchFamily="34" charset="-122"/>
+                <a:cs typeface="Work Sans" pitchFamily="34" charset="-120"/>
+              </a:rPr>
+              <a:t>Beginner English Tips</a:t>
+            </a:r>
+            <a:endParaRPr lang="en-US" sz="1400" dirty="0"/>
+          </a:p>
+        </p:txBody>
+      </p:sp>
+      <p:sp>
+        <p:nvSpPr>
+          <p:cNvPr id="6" name="Text 6"/>
+          <p:cNvSpPr/>
+          <p:nvPr>
+            <p:ph idx="106" type="title" hasCustomPrompt="1"/>
+          </p:nvPr>
+        </p:nvSpPr>
+        <p:spPr>
+          <a:xfrm>
+            <a:off x="548640" y="914400"/>
+            <a:ext cx="11064240" cy="822960"/>
+          </a:xfrm>
+          <a:prstGeom prst="rect">
+            <a:avLst/>
+          </a:prstGeom>
+          <a:noFill/>
+          <a:ln/>
+        </p:spPr>
+        <p:txBody>
+          <a:bodyPr wrap="square" lIns="0" tIns="0" rIns="0" bIns="0" rtlCol="0" anchor="ctr"/>
+          <a:lstStyle/>
+          <a:p>
+            <a:pPr algn="l" indent="0" marL="0">
+              <a:buNone/>
+            </a:pPr>
+            <a:r>
+              <a:rPr lang="en-US" sz="3600" b="1" dirty="0">
+                <a:solidFill>
+                  <a:schemeClr val="tx1"/>
+                </a:solidFill>
+                <a:latin typeface="Big Shoulders Display" pitchFamily="34" charset="0"/>
+                <a:ea typeface="Big Shoulders Display" pitchFamily="34" charset="-122"/>
+                <a:cs typeface="Big Shoulders Display" pitchFamily="34" charset="-120"/>
+              </a:rPr>
               <a:t>COMPROBACIÓN: ÚLTIMO INTENTO</a:t>
             </a:r>
             <a:endParaRPr lang="en-US" sz="3600" dirty="0"/>
@@ -7343,7 +8578,7 @@
       </p:sp>
       <p:sp>
         <p:nvSpPr>
-          <p:cNvPr id="3" name="Tarjeta escucha"/>
+          <p:cNvPr id="7" name="Tarjeta escucha"/>
           <p:cNvSpPr/>
           <p:nvPr/>
         </p:nvSpPr>
@@ -7370,7 +8605,7 @@
       </p:sp>
       <p:pic>
         <p:nvPicPr>
-          <p:cNvPr id="4" name="Ícono audio" descr="Altavoz">    </p:cNvPr>
+          <p:cNvPr id="8" name="Ícono audio" descr="Altavoz">    </p:cNvPr>
           <p:cNvPicPr>
             <a:picLocks noChangeAspect="1"/>
           </p:cNvPicPr>
@@ -7394,7 +8629,7 @@
       </p:pic>
       <p:sp>
         <p:nvSpPr>
-          <p:cNvPr id="5" name="Escucha"/>
+          <p:cNvPr id="9" name="Escucha"/>
           <p:cNvSpPr txBox="1"/>
           <p:nvPr/>
         </p:nvSpPr>
@@ -7456,7 +8691,7 @@
       </p:sp>
       <p:sp>
         <p:nvSpPr>
-          <p:cNvPr id="6" name="Tarjeta pedir repetición"/>
+          <p:cNvPr id="10" name="Tarjeta pedir repetición"/>
           <p:cNvSpPr/>
           <p:nvPr/>
         </p:nvSpPr>
@@ -7483,7 +8718,7 @@
       </p:sp>
       <p:pic>
         <p:nvPicPr>
-          <p:cNvPr id="7" name="Ícono pregunta" descr="Pregunta">    </p:cNvPr>
+          <p:cNvPr id="11" name="Ícono pregunta" descr="Pregunta">    </p:cNvPr>
           <p:cNvPicPr>
             <a:picLocks noChangeAspect="1"/>
           </p:cNvPicPr>
@@ -7507,7 +8742,7 @@
       </p:pic>
       <p:sp>
         <p:nvSpPr>
-          <p:cNvPr id="8" name="Pedir repetición"/>
+          <p:cNvPr id="12" name="Pedir repetición"/>
           <p:cNvSpPr txBox="1"/>
           <p:nvPr/>
         </p:nvSpPr>
@@ -7546,7 +8781,7 @@
       </p:sp>
       <p:sp>
         <p:nvSpPr>
-          <p:cNvPr id="9" name="Barra pregunta"/>
+          <p:cNvPr id="13" name="Barra pregunta"/>
           <p:cNvSpPr/>
           <p:nvPr/>
         </p:nvSpPr>
@@ -7573,7 +8808,7 @@
       </p:sp>
       <p:sp>
         <p:nvSpPr>
-          <p:cNvPr id="10" name="Pregunta"/>
+          <p:cNvPr id="14" name="Pregunta"/>
           <p:cNvSpPr txBox="1"/>
           <p:nvPr/>
         </p:nvSpPr>

</xml_diff>

<commit_message>
Play practice listening phrases at normal volume
Co-Authored-By: Claude Sonnet 5.5 <noreply@anthropic.com>
Claude-Session: https://claude.ai/code/session_01AK9pnJM83quWWTt8tkL4QY
</commit_message>
<xml_diff>
--- a/microclase-pedir-repetir.pptx
+++ b/microclase-pedir-repetir.pptx
@@ -117,49 +117,49 @@
   <p:extLst>
     <p:ext uri="{521415D9-36F7-43E2-AB2F-B90AF26B5E84}">
       <p14:sectionLst xmlns:p14="http://schemas.microsoft.com/office/powerpoint/2010/main">
-        <p14:section name="Apertura" id="{d0058f10-0226-132d-b8f7-5cea3739647d}">
+        <p14:section name="Apertura" id="{9674c843-3860-9395-1b4a-5d72c175f6cb}">
           <p14:sldIdLst>
             <p14:sldId id="256"/>
           </p14:sldIdLst>
         </p14:section>
-        <p14:section name="Situación" id="{7a8208f8-8dbc-c459-2f7e-b0c82fc18d93}">
+        <p14:section name="Situación" id="{adc323d7-d2af-07c1-2a86-5211febc1c02}">
           <p14:sldIdLst>
             <p14:sldId id="257"/>
           </p14:sldIdLst>
         </p14:section>
-        <p14:section name="Expresión 1" id="{8829f43a-c92b-7990-a9f3-1ba954a28023}">
+        <p14:section name="Expresión 1" id="{82bf74a4-c5a4-da71-2354-5b0969e67ca7}">
           <p14:sldIdLst>
             <p14:sldId id="258"/>
           </p14:sldIdLst>
         </p14:section>
-        <p14:section name="Modelado" id="{bcf3456a-59cf-c025-cb59-0612ef634003}">
+        <p14:section name="Modelado" id="{61a6eed8-82f2-2ea6-fdbb-1ed1012f8233}">
           <p14:sldIdLst>
             <p14:sldId id="259"/>
           </p14:sldIdLst>
         </p14:section>
-        <p14:section name="Expresión 2" id="{9901df5f-e4c7-10ae-67fa-5c365fdb5670}">
+        <p14:section name="Expresión 2" id="{34454ba9-5c72-7123-a004-eecb07ae2972}">
           <p14:sldIdLst>
             <p14:sldId id="260"/>
           </p14:sldIdLst>
         </p14:section>
-        <p14:section name="Ejemplo" id="{08cb9061-87cc-8185-1a1a-90537d9cc8aa}">
+        <p14:section name="Ejemplo" id="{2376e720-5f90-8416-5991-001cc071d9d2}">
           <p14:sldIdLst>
             <p14:sldId id="261"/>
           </p14:sldIdLst>
         </p14:section>
-        <p14:section name="Práctica guiada" id="{7174dcd9-e18c-3657-b84c-b3dc9cf983cd}">
+        <p14:section name="Práctica guiada" id="{7be57f35-07c0-0c1a-b96b-25541bd9c907}">
           <p14:sldIdLst>
             <p14:sldId id="262"/>
             <p14:sldId id="263"/>
           </p14:sldIdLst>
         </p14:section>
-        <p14:section name="Comprobación" id="{a6b2eee7-b774-26f5-517c-1837cf296c0d}">
+        <p14:section name="Comprobación" id="{b985913d-a8a5-282c-056f-54ff859536eb}">
           <p14:sldIdLst>
             <p14:sldId id="264"/>
             <p14:sldId id="265"/>
           </p14:sldIdLst>
         </p14:section>
-        <p14:section name="Cierre" id="{d877ee90-3c5f-5511-3945-c9c10375c473}">
+        <p14:section name="Cierre" id="{f22eb5c2-7bb6-3a4b-13c9-a10a41f2f589}">
           <p14:sldIdLst>
             <p14:sldId id="266"/>
           </p14:sldIdLst>
@@ -1289,7 +1289,7 @@
               <a:rPr lang="en-US" dirty="0"/>
               <a:t>[3:25–3:55] PRÁCTICA GUIADA
 Ahora te toca. Escucha: “I’m from Colombia, and I live in Miami.” (Pausa de 5 segundos.) ¿Qué puedes decir si no escuchaste bien? (Pausa de 4 segundos.)
-Audio: reprodúcelo con volumen bajo.</a:t>
+Audio: reprodúcelo con volumen normal y claro, para que el alumno pueda hacer el ejercicio.</a:t>
             </a:r>
             <a:endParaRPr lang="en-US" dirty="0"/>
           </a:p>

</xml_diff>